<commit_message>
fix: rebuild pptx layout (anchor/fonts/aspect)
</commit_message>
<xml_diff>
--- a/kadai.pptx
+++ b/kadai.pptx
@@ -3111,7 +3111,7 @@
         <p:spPr>
           <a:xfrm>
             <a:off x="548640" y="274320"/>
-            <a:ext cx="10972800" cy="365760"/>
+            <a:ext cx="11064240" cy="365760"/>
           </a:xfrm>
           <a:prstGeom prst="rect">
             <a:avLst/>
@@ -3119,20 +3119,27 @@
           <a:noFill/>
         </p:spPr>
         <p:txBody>
-          <a:bodyPr wrap="square">
-            <a:spAutoFit/>
+          <a:bodyPr wrap="square" lIns="0" rIns="0" anchor="t">
+            <a:noAutofit/>
           </a:bodyPr>
           <a:lstStyle/>
           <a:p>
             <a:pPr algn="l">
+              <a:lnSpc>
+                <a:spcPct val="115000"/>
+              </a:lnSpc>
               <a:defRPr sz="1200" b="0">
                 <a:solidFill>
                   <a:srgbClr val="6B6F6B"/>
                 </a:solidFill>
-                <a:latin typeface="Yu Gothic"/>
               </a:defRPr>
             </a:pPr>
             <a:r>
+              <a:rPr>
+                <a:latin typeface="Meiryo"/>
+                <a:ea typeface="Meiryo"/>
+                <a:cs typeface="Meiryo"/>
+              </a:rPr>
               <a:t>● 特別演習II — ゴール − 現状 ＝ 課題</a:t>
             </a:r>
           </a:p>
@@ -3146,8 +3153,8 @@
         </p:nvSpPr>
         <p:spPr>
           <a:xfrm>
-            <a:off x="548640" y="731520"/>
-            <a:ext cx="10972800" cy="1828800"/>
+            <a:off x="548640" y="685800"/>
+            <a:ext cx="11064240" cy="1371600"/>
           </a:xfrm>
           <a:prstGeom prst="rect">
             <a:avLst/>
@@ -3155,20 +3162,27 @@
           <a:noFill/>
         </p:spPr>
         <p:txBody>
-          <a:bodyPr wrap="square">
-            <a:spAutoFit/>
+          <a:bodyPr wrap="square" lIns="0" rIns="0" anchor="t">
+            <a:noAutofit/>
           </a:bodyPr>
           <a:lstStyle/>
           <a:p>
             <a:pPr algn="l">
-              <a:defRPr sz="5000" b="1">
+              <a:lnSpc>
+                <a:spcPct val="115000"/>
+              </a:lnSpc>
+              <a:defRPr sz="4400" b="1">
                 <a:solidFill>
                   <a:srgbClr val="111311"/>
                 </a:solidFill>
-                <a:latin typeface="Yu Gothic"/>
               </a:defRPr>
             </a:pPr>
             <a:r>
+              <a:rPr>
+                <a:latin typeface="Meiryo"/>
+                <a:ea typeface="Meiryo"/>
+                <a:cs typeface="Meiryo"/>
+              </a:rPr>
               <a:t>ゴール − 現状 ＝ 課題</a:t>
             </a:r>
           </a:p>
@@ -3182,8 +3196,8 @@
         </p:nvSpPr>
         <p:spPr>
           <a:xfrm>
-            <a:off x="548640" y="2560320"/>
-            <a:ext cx="7315200" cy="914400"/>
+            <a:off x="548640" y="2103120"/>
+            <a:ext cx="7772400" cy="548640"/>
           </a:xfrm>
           <a:prstGeom prst="rect">
             <a:avLst/>
@@ -3191,20 +3205,27 @@
           <a:noFill/>
         </p:spPr>
         <p:txBody>
-          <a:bodyPr wrap="square">
-            <a:spAutoFit/>
+          <a:bodyPr wrap="square" lIns="0" rIns="0" anchor="t">
+            <a:noAutofit/>
           </a:bodyPr>
           <a:lstStyle/>
           <a:p>
             <a:pPr algn="l">
-              <a:defRPr sz="1600" b="0">
+              <a:lnSpc>
+                <a:spcPct val="115000"/>
+              </a:lnSpc>
+              <a:defRPr sz="1500" b="0">
                 <a:solidFill>
                   <a:srgbClr val="333333"/>
                 </a:solidFill>
-                <a:latin typeface="Yu Gothic"/>
               </a:defRPr>
             </a:pPr>
             <a:r>
+              <a:rPr>
+                <a:latin typeface="Meiryo"/>
+                <a:ea typeface="Meiryo"/>
+                <a:cs typeface="Meiryo"/>
+              </a:rPr>
               <a:t>課題設定と課題分析を、図と表で一発理解。</a:t>
             </a:r>
           </a:p>
@@ -3218,16 +3239,18 @@
         </p:nvSpPr>
         <p:spPr>
           <a:xfrm>
-            <a:off x="548640" y="3840480"/>
-            <a:ext cx="3108960" cy="1463040"/>
+            <a:off x="548640" y="3108960"/>
+            <a:ext cx="3108960" cy="1737360"/>
           </a:xfrm>
           <a:prstGeom prst="roundRect">
-            <a:avLst/>
+            <a:avLst>
+              <a:gd name="adj" fmla="val 12000"/>
+            </a:avLst>
           </a:prstGeom>
           <a:solidFill>
             <a:srgbClr val="FFFFFF"/>
           </a:solidFill>
-          <a:ln w="12700">
+          <a:ln w="15875">
             <a:solidFill>
               <a:srgbClr val="E5E1D8"/>
             </a:solidFill>
@@ -3263,8 +3286,8 @@
         </p:nvSpPr>
         <p:spPr>
           <a:xfrm>
-            <a:off x="685800" y="3931920"/>
-            <a:ext cx="2834640" cy="1280160"/>
+            <a:off x="731520" y="3246120"/>
+            <a:ext cx="2743200" cy="1463039"/>
           </a:xfrm>
           <a:prstGeom prst="rect">
             <a:avLst/>
@@ -3272,24 +3295,36 @@
           <a:noFill/>
         </p:spPr>
         <p:txBody>
-          <a:bodyPr wrap="square">
-            <a:spAutoFit/>
+          <a:bodyPr wrap="square" lIns="0" rIns="0" anchor="t">
+            <a:noAutofit/>
           </a:bodyPr>
           <a:lstStyle/>
           <a:p>
             <a:pPr algn="ctr">
-              <a:defRPr sz="1600" b="1">
+              <a:lnSpc>
+                <a:spcPct val="115000"/>
+              </a:lnSpc>
+              <a:defRPr sz="1400" b="1">
                 <a:solidFill>
                   <a:srgbClr val="111311"/>
                 </a:solidFill>
-                <a:latin typeface="Yu Gothic"/>
               </a:defRPr>
             </a:pPr>
             <a:r>
+              <a:rPr>
+                <a:latin typeface="Meiryo"/>
+                <a:ea typeface="Meiryo"/>
+                <a:cs typeface="Meiryo"/>
+              </a:rPr>
               <a:t>ゴール（理想）</a:t>
             </a:r>
             <a:br/>
             <a:r>
+              <a:rPr>
+                <a:latin typeface="Meiryo"/>
+                <a:ea typeface="Meiryo"/>
+                <a:cs typeface="Meiryo"/>
+              </a:rPr>
               <a:t>十分な自己理解</a:t>
             </a:r>
           </a:p>
@@ -3303,8 +3338,8 @@
         </p:nvSpPr>
         <p:spPr>
           <a:xfrm>
-            <a:off x="3749039" y="4297680"/>
-            <a:ext cx="457200" cy="548640"/>
+            <a:off x="3703320" y="3657600"/>
+            <a:ext cx="502920" cy="640080"/>
           </a:xfrm>
           <a:prstGeom prst="rect">
             <a:avLst/>
@@ -3312,20 +3347,27 @@
           <a:noFill/>
         </p:spPr>
         <p:txBody>
-          <a:bodyPr wrap="square">
-            <a:spAutoFit/>
+          <a:bodyPr wrap="square" lIns="0" rIns="0" anchor="t">
+            <a:noAutofit/>
           </a:bodyPr>
           <a:lstStyle/>
           <a:p>
             <a:pPr algn="ctr">
+              <a:lnSpc>
+                <a:spcPct val="115000"/>
+              </a:lnSpc>
               <a:defRPr sz="2800" b="1">
                 <a:solidFill>
                   <a:srgbClr val="111311"/>
                 </a:solidFill>
-                <a:latin typeface="Yu Gothic"/>
               </a:defRPr>
             </a:pPr>
             <a:r>
+              <a:rPr>
+                <a:latin typeface="Meiryo"/>
+                <a:ea typeface="Meiryo"/>
+                <a:cs typeface="Meiryo"/>
+              </a:rPr>
               <a:t>−</a:t>
             </a:r>
           </a:p>
@@ -3339,16 +3381,18 @@
         </p:nvSpPr>
         <p:spPr>
           <a:xfrm>
-            <a:off x="4297680" y="3840480"/>
-            <a:ext cx="3108960" cy="1463040"/>
+            <a:off x="4297680" y="3108960"/>
+            <a:ext cx="3108960" cy="1737360"/>
           </a:xfrm>
           <a:prstGeom prst="roundRect">
-            <a:avLst/>
+            <a:avLst>
+              <a:gd name="adj" fmla="val 12000"/>
+            </a:avLst>
           </a:prstGeom>
           <a:solidFill>
             <a:srgbClr val="FFFFFF"/>
           </a:solidFill>
-          <a:ln w="12700">
+          <a:ln w="15875">
             <a:solidFill>
               <a:srgbClr val="E5E1D8"/>
             </a:solidFill>
@@ -3384,8 +3428,8 @@
         </p:nvSpPr>
         <p:spPr>
           <a:xfrm>
-            <a:off x="4434840" y="3931920"/>
-            <a:ext cx="2834640" cy="1280160"/>
+            <a:off x="4480560" y="3246120"/>
+            <a:ext cx="2743200" cy="1463039"/>
           </a:xfrm>
           <a:prstGeom prst="rect">
             <a:avLst/>
@@ -3393,24 +3437,36 @@
           <a:noFill/>
         </p:spPr>
         <p:txBody>
-          <a:bodyPr wrap="square">
-            <a:spAutoFit/>
+          <a:bodyPr wrap="square" lIns="0" rIns="0" anchor="t">
+            <a:noAutofit/>
           </a:bodyPr>
           <a:lstStyle/>
           <a:p>
             <a:pPr algn="ctr">
-              <a:defRPr sz="1600" b="1">
+              <a:lnSpc>
+                <a:spcPct val="115000"/>
+              </a:lnSpc>
+              <a:defRPr sz="1400" b="1">
                 <a:solidFill>
                   <a:srgbClr val="111311"/>
                 </a:solidFill>
-                <a:latin typeface="Yu Gothic"/>
               </a:defRPr>
             </a:pPr>
             <a:r>
+              <a:rPr>
+                <a:latin typeface="Meiryo"/>
+                <a:ea typeface="Meiryo"/>
+                <a:cs typeface="Meiryo"/>
+              </a:rPr>
               <a:t>現状</a:t>
             </a:r>
             <a:br/>
             <a:r>
+              <a:rPr>
+                <a:latin typeface="Meiryo"/>
+                <a:ea typeface="Meiryo"/>
+                <a:cs typeface="Meiryo"/>
+              </a:rPr>
               <a:t>手順もゴールも不明</a:t>
             </a:r>
           </a:p>
@@ -3424,8 +3480,8 @@
         </p:nvSpPr>
         <p:spPr>
           <a:xfrm>
-            <a:off x="7498079" y="4297680"/>
-            <a:ext cx="457200" cy="548640"/>
+            <a:off x="7452360" y="3657600"/>
+            <a:ext cx="502920" cy="640080"/>
           </a:xfrm>
           <a:prstGeom prst="rect">
             <a:avLst/>
@@ -3433,20 +3489,27 @@
           <a:noFill/>
         </p:spPr>
         <p:txBody>
-          <a:bodyPr wrap="square">
-            <a:spAutoFit/>
+          <a:bodyPr wrap="square" lIns="0" rIns="0" anchor="t">
+            <a:noAutofit/>
           </a:bodyPr>
           <a:lstStyle/>
           <a:p>
             <a:pPr algn="ctr">
+              <a:lnSpc>
+                <a:spcPct val="115000"/>
+              </a:lnSpc>
               <a:defRPr sz="2800" b="1">
                 <a:solidFill>
                   <a:srgbClr val="111311"/>
                 </a:solidFill>
-                <a:latin typeface="Yu Gothic"/>
               </a:defRPr>
             </a:pPr>
             <a:r>
+              <a:rPr>
+                <a:latin typeface="Meiryo"/>
+                <a:ea typeface="Meiryo"/>
+                <a:cs typeface="Meiryo"/>
+              </a:rPr>
               <a:t>＝</a:t>
             </a:r>
           </a:p>
@@ -3460,16 +3523,18 @@
         </p:nvSpPr>
         <p:spPr>
           <a:xfrm>
-            <a:off x="8046720" y="3840480"/>
-            <a:ext cx="3474720" cy="1463040"/>
+            <a:off x="8046720" y="3108960"/>
+            <a:ext cx="3566160" cy="1737360"/>
           </a:xfrm>
           <a:prstGeom prst="roundRect">
-            <a:avLst/>
+            <a:avLst>
+              <a:gd name="adj" fmla="val 12000"/>
+            </a:avLst>
           </a:prstGeom>
           <a:solidFill>
-            <a:srgbClr val="B91C1C"/>
+            <a:srgbClr val="FFFFFF"/>
           </a:solidFill>
-          <a:ln w="12700">
+          <a:ln w="15875">
             <a:solidFill>
               <a:srgbClr val="B91C1C"/>
             </a:solidFill>
@@ -3505,8 +3570,8 @@
         </p:nvSpPr>
         <p:spPr>
           <a:xfrm>
-            <a:off x="8183880" y="3931920"/>
-            <a:ext cx="3200400" cy="1280160"/>
+            <a:off x="8229600" y="3246120"/>
+            <a:ext cx="3200400" cy="1463039"/>
           </a:xfrm>
           <a:prstGeom prst="rect">
             <a:avLst/>
@@ -3514,25 +3579,80 @@
           <a:noFill/>
         </p:spPr>
         <p:txBody>
-          <a:bodyPr wrap="square">
-            <a:spAutoFit/>
+          <a:bodyPr wrap="square" lIns="0" rIns="0" anchor="t">
+            <a:noAutofit/>
           </a:bodyPr>
           <a:lstStyle/>
           <a:p>
             <a:pPr algn="ctr">
-              <a:defRPr sz="1600" b="1">
+              <a:lnSpc>
+                <a:spcPct val="115000"/>
+              </a:lnSpc>
+              <a:defRPr sz="1400" b="1">
                 <a:solidFill>
                   <a:srgbClr val="B91C1C"/>
                 </a:solidFill>
-                <a:latin typeface="Yu Gothic"/>
               </a:defRPr>
             </a:pPr>
             <a:r>
+              <a:rPr>
+                <a:latin typeface="Meiryo"/>
+                <a:ea typeface="Meiryo"/>
+                <a:cs typeface="Meiryo"/>
+              </a:rPr>
               <a:t>課題</a:t>
             </a:r>
             <a:br/>
             <a:r>
+              <a:rPr>
+                <a:latin typeface="Meiryo"/>
+                <a:ea typeface="Meiryo"/>
+                <a:cs typeface="Meiryo"/>
+              </a:rPr>
               <a:t>苦戦したまま選考へ</a:t>
+            </a:r>
+          </a:p>
+        </p:txBody>
+      </p:sp>
+      <p:sp>
+        <p:nvSpPr>
+          <p:cNvPr id="13" name="TextBox 12"/>
+          <p:cNvSpPr txBox="1"/>
+          <p:nvPr/>
+        </p:nvSpPr>
+        <p:spPr>
+          <a:xfrm>
+            <a:off x="548640" y="5212080"/>
+            <a:ext cx="11064240" cy="457200"/>
+          </a:xfrm>
+          <a:prstGeom prst="rect">
+            <a:avLst/>
+          </a:prstGeom>
+          <a:noFill/>
+        </p:spPr>
+        <p:txBody>
+          <a:bodyPr wrap="square" lIns="0" rIns="0" anchor="t">
+            <a:noAutofit/>
+          </a:bodyPr>
+          <a:lstStyle/>
+          <a:p>
+            <a:pPr algn="ctr">
+              <a:lnSpc>
+                <a:spcPct val="115000"/>
+              </a:lnSpc>
+              <a:defRPr sz="1200" b="0">
+                <a:solidFill>
+                  <a:srgbClr val="6B6F6B"/>
+                </a:solidFill>
+              </a:defRPr>
+            </a:pPr>
+            <a:r>
+              <a:rPr>
+                <a:latin typeface="Meiryo"/>
+                <a:ea typeface="Meiryo"/>
+                <a:cs typeface="Meiryo"/>
+              </a:rPr>
+              <a:t>発表の流れ：ゴール → 現状 → 課題設定 → 課題分析①原因 → ②影響 → まとめ</a:t>
             </a:r>
           </a:p>
         </p:txBody>
@@ -3571,8 +3691,8 @@
         </p:nvSpPr>
         <p:spPr>
           <a:xfrm>
-            <a:off x="548640" y="182880"/>
-            <a:ext cx="10972800" cy="365760"/>
+            <a:off x="548640" y="228600"/>
+            <a:ext cx="11064240" cy="365760"/>
           </a:xfrm>
           <a:prstGeom prst="rect">
             <a:avLst/>
@@ -3580,20 +3700,27 @@
           <a:noFill/>
         </p:spPr>
         <p:txBody>
-          <a:bodyPr wrap="square">
-            <a:spAutoFit/>
+          <a:bodyPr wrap="square" lIns="0" rIns="0" anchor="t">
+            <a:noAutofit/>
           </a:bodyPr>
           <a:lstStyle/>
           <a:p>
             <a:pPr algn="l">
+              <a:lnSpc>
+                <a:spcPct val="115000"/>
+              </a:lnSpc>
               <a:defRPr sz="1200" b="0">
                 <a:solidFill>
                   <a:srgbClr val="6B6F6B"/>
                 </a:solidFill>
-                <a:latin typeface="Yu Gothic"/>
               </a:defRPr>
             </a:pPr>
             <a:r>
+              <a:rPr>
+                <a:latin typeface="Meiryo"/>
+                <a:ea typeface="Meiryo"/>
+                <a:cs typeface="Meiryo"/>
+              </a:rPr>
               <a:t>(01) ゴール（理想）— あるべき姿</a:t>
             </a:r>
           </a:p>
@@ -3607,8 +3734,8 @@
         </p:nvSpPr>
         <p:spPr>
           <a:xfrm>
-            <a:off x="548640" y="548640"/>
-            <a:ext cx="10972800" cy="822960"/>
+            <a:off x="548640" y="594360"/>
+            <a:ext cx="11064240" cy="822960"/>
           </a:xfrm>
           <a:prstGeom prst="rect">
             <a:avLst/>
@@ -3616,20 +3743,27 @@
           <a:noFill/>
         </p:spPr>
         <p:txBody>
-          <a:bodyPr wrap="square">
-            <a:spAutoFit/>
+          <a:bodyPr wrap="square" lIns="0" rIns="0" anchor="t">
+            <a:noAutofit/>
           </a:bodyPr>
           <a:lstStyle/>
           <a:p>
             <a:pPr algn="l">
-              <a:defRPr sz="3400" b="1">
+              <a:lnSpc>
+                <a:spcPct val="115000"/>
+              </a:lnSpc>
+              <a:defRPr sz="3000" b="1">
                 <a:solidFill>
                   <a:srgbClr val="111311"/>
                 </a:solidFill>
-                <a:latin typeface="Yu Gothic"/>
               </a:defRPr>
             </a:pPr>
             <a:r>
+              <a:rPr>
+                <a:latin typeface="Meiryo"/>
+                <a:ea typeface="Meiryo"/>
+                <a:cs typeface="Meiryo"/>
+              </a:rPr>
               <a:t>ゴールは3条件。</a:t>
             </a:r>
           </a:p>
@@ -3643,16 +3777,18 @@
         </p:nvSpPr>
         <p:spPr>
           <a:xfrm>
-            <a:off x="548640" y="1645920"/>
-            <a:ext cx="11064240" cy="640080"/>
+            <a:off x="548640" y="1554480"/>
+            <a:ext cx="11064240" cy="594360"/>
           </a:xfrm>
           <a:prstGeom prst="roundRect">
-            <a:avLst/>
+            <a:avLst>
+              <a:gd name="adj" fmla="val 12000"/>
+            </a:avLst>
           </a:prstGeom>
           <a:solidFill>
             <a:srgbClr val="111311"/>
           </a:solidFill>
-          <a:ln w="12700">
+          <a:ln w="15875">
             <a:solidFill>
               <a:srgbClr val="111311"/>
             </a:solidFill>
@@ -3688,8 +3824,8 @@
         </p:nvSpPr>
         <p:spPr>
           <a:xfrm>
-            <a:off x="822960" y="1737360"/>
-            <a:ext cx="2743200" cy="457200"/>
+            <a:off x="868680" y="1645920"/>
+            <a:ext cx="2743200" cy="411480"/>
           </a:xfrm>
           <a:prstGeom prst="rect">
             <a:avLst/>
@@ -3697,20 +3833,27 @@
           <a:noFill/>
         </p:spPr>
         <p:txBody>
-          <a:bodyPr wrap="square">
-            <a:spAutoFit/>
+          <a:bodyPr wrap="square" lIns="0" rIns="0" anchor="t">
+            <a:noAutofit/>
           </a:bodyPr>
           <a:lstStyle/>
           <a:p>
             <a:pPr algn="l">
+              <a:lnSpc>
+                <a:spcPct val="115000"/>
+              </a:lnSpc>
               <a:defRPr sz="1300" b="1">
                 <a:solidFill>
                   <a:srgbClr val="FFFFFF"/>
                 </a:solidFill>
-                <a:latin typeface="Yu Gothic"/>
               </a:defRPr>
             </a:pPr>
             <a:r>
+              <a:rPr>
+                <a:latin typeface="Meiryo"/>
+                <a:ea typeface="Meiryo"/>
+                <a:cs typeface="Meiryo"/>
+              </a:rPr>
               <a:t>条件</a:t>
             </a:r>
           </a:p>
@@ -3724,8 +3867,8 @@
         </p:nvSpPr>
         <p:spPr>
           <a:xfrm>
-            <a:off x="3749039" y="1737360"/>
-            <a:ext cx="4114800" cy="457200"/>
+            <a:off x="3840480" y="1645920"/>
+            <a:ext cx="4206240" cy="411480"/>
           </a:xfrm>
           <a:prstGeom prst="rect">
             <a:avLst/>
@@ -3733,20 +3876,27 @@
           <a:noFill/>
         </p:spPr>
         <p:txBody>
-          <a:bodyPr wrap="square">
-            <a:spAutoFit/>
+          <a:bodyPr wrap="square" lIns="0" rIns="0" anchor="t">
+            <a:noAutofit/>
           </a:bodyPr>
           <a:lstStyle/>
           <a:p>
             <a:pPr algn="l">
+              <a:lnSpc>
+                <a:spcPct val="115000"/>
+              </a:lnSpc>
               <a:defRPr sz="1300" b="1">
                 <a:solidFill>
                   <a:srgbClr val="FFFFFF"/>
                 </a:solidFill>
-                <a:latin typeface="Yu Gothic"/>
               </a:defRPr>
             </a:pPr>
             <a:r>
+              <a:rPr>
+                <a:latin typeface="Meiryo"/>
+                <a:ea typeface="Meiryo"/>
+                <a:cs typeface="Meiryo"/>
+              </a:rPr>
               <a:t>内容</a:t>
             </a:r>
           </a:p>
@@ -3760,8 +3910,8 @@
         </p:nvSpPr>
         <p:spPr>
           <a:xfrm>
-            <a:off x="8229600" y="1737360"/>
-            <a:ext cx="3200400" cy="457200"/>
+            <a:off x="8321040" y="1645920"/>
+            <a:ext cx="3108960" cy="411480"/>
           </a:xfrm>
           <a:prstGeom prst="rect">
             <a:avLst/>
@@ -3769,20 +3919,27 @@
           <a:noFill/>
         </p:spPr>
         <p:txBody>
-          <a:bodyPr wrap="square">
-            <a:spAutoFit/>
+          <a:bodyPr wrap="square" lIns="0" rIns="0" anchor="t">
+            <a:noAutofit/>
           </a:bodyPr>
           <a:lstStyle/>
           <a:p>
             <a:pPr algn="l">
+              <a:lnSpc>
+                <a:spcPct val="115000"/>
+              </a:lnSpc>
               <a:defRPr sz="1300" b="1">
                 <a:solidFill>
                   <a:srgbClr val="FFFFFF"/>
                 </a:solidFill>
-                <a:latin typeface="Yu Gothic"/>
               </a:defRPr>
             </a:pPr>
             <a:r>
+              <a:rPr>
+                <a:latin typeface="Meiryo"/>
+                <a:ea typeface="Meiryo"/>
+                <a:cs typeface="Meiryo"/>
+              </a:rPr>
               <a:t>測り方</a:t>
             </a:r>
           </a:p>
@@ -3796,16 +3953,18 @@
         </p:nvSpPr>
         <p:spPr>
           <a:xfrm>
-            <a:off x="548640" y="2377440"/>
-            <a:ext cx="11064240" cy="822960"/>
+            <a:off x="548640" y="2286000"/>
+            <a:ext cx="11064240" cy="914400"/>
           </a:xfrm>
           <a:prstGeom prst="roundRect">
-            <a:avLst/>
+            <a:avLst>
+              <a:gd name="adj" fmla="val 12000"/>
+            </a:avLst>
           </a:prstGeom>
           <a:solidFill>
             <a:srgbClr val="FFFFFF"/>
           </a:solidFill>
-          <a:ln w="12700">
+          <a:ln w="15875">
             <a:solidFill>
               <a:srgbClr val="E5E1D8"/>
             </a:solidFill>
@@ -3841,8 +4000,8 @@
         </p:nvSpPr>
         <p:spPr>
           <a:xfrm>
-            <a:off x="822960" y="2468880"/>
-            <a:ext cx="2743200" cy="640080"/>
+            <a:off x="868680" y="2395728"/>
+            <a:ext cx="2743200" cy="685800"/>
           </a:xfrm>
           <a:prstGeom prst="rect">
             <a:avLst/>
@@ -3850,20 +4009,27 @@
           <a:noFill/>
         </p:spPr>
         <p:txBody>
-          <a:bodyPr wrap="square">
-            <a:spAutoFit/>
+          <a:bodyPr wrap="square" lIns="0" rIns="0" anchor="t">
+            <a:noAutofit/>
           </a:bodyPr>
           <a:lstStyle/>
           <a:p>
             <a:pPr algn="l">
+              <a:lnSpc>
+                <a:spcPct val="115000"/>
+              </a:lnSpc>
               <a:defRPr sz="1400" b="1">
                 <a:solidFill>
                   <a:srgbClr val="111311"/>
                 </a:solidFill>
-                <a:latin typeface="Yu Gothic"/>
               </a:defRPr>
             </a:pPr>
             <a:r>
+              <a:rPr>
+                <a:latin typeface="Meiryo"/>
+                <a:ea typeface="Meiryo"/>
+                <a:cs typeface="Meiryo"/>
+              </a:rPr>
               <a:t>① 語れる</a:t>
             </a:r>
           </a:p>
@@ -3877,8 +4043,8 @@
         </p:nvSpPr>
         <p:spPr>
           <a:xfrm>
-            <a:off x="3749039" y="2468880"/>
-            <a:ext cx="4114800" cy="640080"/>
+            <a:off x="3840480" y="2395728"/>
+            <a:ext cx="4206240" cy="685800"/>
           </a:xfrm>
           <a:prstGeom prst="rect">
             <a:avLst/>
@@ -3886,20 +4052,27 @@
           <a:noFill/>
         </p:spPr>
         <p:txBody>
-          <a:bodyPr wrap="square">
-            <a:spAutoFit/>
+          <a:bodyPr wrap="square" lIns="0" rIns="0" anchor="t">
+            <a:noAutofit/>
           </a:bodyPr>
           <a:lstStyle/>
           <a:p>
             <a:pPr algn="l">
-              <a:defRPr sz="1300" b="0">
+              <a:lnSpc>
+                <a:spcPct val="115000"/>
+              </a:lnSpc>
+              <a:defRPr sz="1200" b="0">
                 <a:solidFill>
                   <a:srgbClr val="111311"/>
                 </a:solidFill>
-                <a:latin typeface="Yu Gothic"/>
               </a:defRPr>
             </a:pPr>
             <a:r>
+              <a:rPr>
+                <a:latin typeface="Meiryo"/>
+                <a:ea typeface="Meiryo"/>
+                <a:cs typeface="Meiryo"/>
+              </a:rPr>
               <a:t>強みを経験と結びつけて話せる</a:t>
             </a:r>
           </a:p>
@@ -3913,8 +4086,8 @@
         </p:nvSpPr>
         <p:spPr>
           <a:xfrm>
-            <a:off x="8229600" y="2468880"/>
-            <a:ext cx="3200400" cy="640080"/>
+            <a:off x="8321040" y="2395728"/>
+            <a:ext cx="3108960" cy="685800"/>
           </a:xfrm>
           <a:prstGeom prst="rect">
             <a:avLst/>
@@ -3922,20 +4095,27 @@
           <a:noFill/>
         </p:spPr>
         <p:txBody>
-          <a:bodyPr wrap="square">
-            <a:spAutoFit/>
+          <a:bodyPr wrap="square" lIns="0" rIns="0" anchor="t">
+            <a:noAutofit/>
           </a:bodyPr>
           <a:lstStyle/>
           <a:p>
             <a:pPr algn="l">
-              <a:defRPr sz="1200" b="0">
+              <a:lnSpc>
+                <a:spcPct val="115000"/>
+              </a:lnSpc>
+              <a:defRPr sz="1100" b="0">
                 <a:solidFill>
                   <a:srgbClr val="6B6F6B"/>
                 </a:solidFill>
-                <a:latin typeface="Yu Gothic"/>
               </a:defRPr>
             </a:pPr>
             <a:r>
+              <a:rPr>
+                <a:latin typeface="Meiryo"/>
+                <a:ea typeface="Meiryo"/>
+                <a:cs typeface="Meiryo"/>
+              </a:rPr>
               <a:t>面接で1分説明できる</a:t>
             </a:r>
           </a:p>
@@ -3949,16 +4129,18 @@
         </p:nvSpPr>
         <p:spPr>
           <a:xfrm>
-            <a:off x="548640" y="3337560"/>
-            <a:ext cx="11064240" cy="822960"/>
+            <a:off x="548640" y="3310128"/>
+            <a:ext cx="11064240" cy="914400"/>
           </a:xfrm>
           <a:prstGeom prst="roundRect">
-            <a:avLst/>
+            <a:avLst>
+              <a:gd name="adj" fmla="val 12000"/>
+            </a:avLst>
           </a:prstGeom>
           <a:solidFill>
             <a:srgbClr val="FFFFFF"/>
           </a:solidFill>
-          <a:ln w="12700">
+          <a:ln w="15875">
             <a:solidFill>
               <a:srgbClr val="E5E1D8"/>
             </a:solidFill>
@@ -3994,8 +4176,8 @@
         </p:nvSpPr>
         <p:spPr>
           <a:xfrm>
-            <a:off x="822960" y="3429000"/>
-            <a:ext cx="2743200" cy="640080"/>
+            <a:off x="868680" y="3419856"/>
+            <a:ext cx="2743200" cy="685800"/>
           </a:xfrm>
           <a:prstGeom prst="rect">
             <a:avLst/>
@@ -4003,20 +4185,27 @@
           <a:noFill/>
         </p:spPr>
         <p:txBody>
-          <a:bodyPr wrap="square">
-            <a:spAutoFit/>
+          <a:bodyPr wrap="square" lIns="0" rIns="0" anchor="t">
+            <a:noAutofit/>
           </a:bodyPr>
           <a:lstStyle/>
           <a:p>
             <a:pPr algn="l">
+              <a:lnSpc>
+                <a:spcPct val="115000"/>
+              </a:lnSpc>
               <a:defRPr sz="1400" b="1">
                 <a:solidFill>
                   <a:srgbClr val="111311"/>
                 </a:solidFill>
-                <a:latin typeface="Yu Gothic"/>
               </a:defRPr>
             </a:pPr>
             <a:r>
+              <a:rPr>
+                <a:latin typeface="Meiryo"/>
+                <a:ea typeface="Meiryo"/>
+                <a:cs typeface="Meiryo"/>
+              </a:rPr>
               <a:t>② 軸がある</a:t>
             </a:r>
           </a:p>
@@ -4030,8 +4219,8 @@
         </p:nvSpPr>
         <p:spPr>
           <a:xfrm>
-            <a:off x="3749039" y="3429000"/>
-            <a:ext cx="4114800" cy="640080"/>
+            <a:off x="3840480" y="3419856"/>
+            <a:ext cx="4206240" cy="685800"/>
           </a:xfrm>
           <a:prstGeom prst="rect">
             <a:avLst/>
@@ -4039,20 +4228,27 @@
           <a:noFill/>
         </p:spPr>
         <p:txBody>
-          <a:bodyPr wrap="square">
-            <a:spAutoFit/>
+          <a:bodyPr wrap="square" lIns="0" rIns="0" anchor="t">
+            <a:noAutofit/>
           </a:bodyPr>
           <a:lstStyle/>
           <a:p>
             <a:pPr algn="l">
-              <a:defRPr sz="1300" b="0">
+              <a:lnSpc>
+                <a:spcPct val="115000"/>
+              </a:lnSpc>
+              <a:defRPr sz="1200" b="0">
                 <a:solidFill>
                   <a:srgbClr val="111311"/>
                 </a:solidFill>
-                <a:latin typeface="Yu Gothic"/>
               </a:defRPr>
             </a:pPr>
             <a:r>
+              <a:rPr>
+                <a:latin typeface="Meiryo"/>
+                <a:ea typeface="Meiryo"/>
+                <a:cs typeface="Meiryo"/>
+              </a:rPr>
               <a:t>避けたい環境・譲れない軸を1つ言える</a:t>
             </a:r>
           </a:p>
@@ -4066,8 +4262,8 @@
         </p:nvSpPr>
         <p:spPr>
           <a:xfrm>
-            <a:off x="8229600" y="3429000"/>
-            <a:ext cx="3200400" cy="640080"/>
+            <a:off x="8321040" y="3419856"/>
+            <a:ext cx="3108960" cy="685800"/>
           </a:xfrm>
           <a:prstGeom prst="rect">
             <a:avLst/>
@@ -4075,20 +4271,27 @@
           <a:noFill/>
         </p:spPr>
         <p:txBody>
-          <a:bodyPr wrap="square">
-            <a:spAutoFit/>
+          <a:bodyPr wrap="square" lIns="0" rIns="0" anchor="t">
+            <a:noAutofit/>
           </a:bodyPr>
           <a:lstStyle/>
           <a:p>
             <a:pPr algn="l">
-              <a:defRPr sz="1200" b="0">
+              <a:lnSpc>
+                <a:spcPct val="115000"/>
+              </a:lnSpc>
+              <a:defRPr sz="1100" b="0">
                 <a:solidFill>
                   <a:srgbClr val="6B6F6B"/>
                 </a:solidFill>
-                <a:latin typeface="Yu Gothic"/>
               </a:defRPr>
             </a:pPr>
             <a:r>
+              <a:rPr>
+                <a:latin typeface="Meiryo"/>
+                <a:ea typeface="Meiryo"/>
+                <a:cs typeface="Meiryo"/>
+              </a:rPr>
               <a:t>企業選びの理由を言える</a:t>
             </a:r>
           </a:p>
@@ -4102,16 +4305,18 @@
         </p:nvSpPr>
         <p:spPr>
           <a:xfrm>
-            <a:off x="548640" y="4297680"/>
-            <a:ext cx="11064240" cy="822960"/>
+            <a:off x="548640" y="4334256"/>
+            <a:ext cx="11064240" cy="914400"/>
           </a:xfrm>
           <a:prstGeom prst="roundRect">
-            <a:avLst/>
+            <a:avLst>
+              <a:gd name="adj" fmla="val 12000"/>
+            </a:avLst>
           </a:prstGeom>
           <a:solidFill>
             <a:srgbClr val="FFFFFF"/>
           </a:solidFill>
-          <a:ln w="12700">
+          <a:ln w="15875">
             <a:solidFill>
               <a:srgbClr val="E5E1D8"/>
             </a:solidFill>
@@ -4147,8 +4352,8 @@
         </p:nvSpPr>
         <p:spPr>
           <a:xfrm>
-            <a:off x="822960" y="4389120"/>
-            <a:ext cx="2743200" cy="640080"/>
+            <a:off x="868680" y="4443984"/>
+            <a:ext cx="2743200" cy="685800"/>
           </a:xfrm>
           <a:prstGeom prst="rect">
             <a:avLst/>
@@ -4156,20 +4361,27 @@
           <a:noFill/>
         </p:spPr>
         <p:txBody>
-          <a:bodyPr wrap="square">
-            <a:spAutoFit/>
+          <a:bodyPr wrap="square" lIns="0" rIns="0" anchor="t">
+            <a:noAutofit/>
           </a:bodyPr>
           <a:lstStyle/>
           <a:p>
             <a:pPr algn="l">
+              <a:lnSpc>
+                <a:spcPct val="115000"/>
+              </a:lnSpc>
               <a:defRPr sz="1400" b="1">
                 <a:solidFill>
                   <a:srgbClr val="111311"/>
                 </a:solidFill>
-                <a:latin typeface="Yu Gothic"/>
               </a:defRPr>
             </a:pPr>
             <a:r>
+              <a:rPr>
+                <a:latin typeface="Meiryo"/>
+                <a:ea typeface="Meiryo"/>
+                <a:cs typeface="Meiryo"/>
+              </a:rPr>
               <a:t>③ 結びつく</a:t>
             </a:r>
           </a:p>
@@ -4183,8 +4395,8 @@
         </p:nvSpPr>
         <p:spPr>
           <a:xfrm>
-            <a:off x="3749039" y="4389120"/>
-            <a:ext cx="4114800" cy="640080"/>
+            <a:off x="3840480" y="4443984"/>
+            <a:ext cx="4206240" cy="685800"/>
           </a:xfrm>
           <a:prstGeom prst="rect">
             <a:avLst/>
@@ -4192,20 +4404,27 @@
           <a:noFill/>
         </p:spPr>
         <p:txBody>
-          <a:bodyPr wrap="square">
-            <a:spAutoFit/>
+          <a:bodyPr wrap="square" lIns="0" rIns="0" anchor="t">
+            <a:noAutofit/>
           </a:bodyPr>
           <a:lstStyle/>
           <a:p>
             <a:pPr algn="l">
-              <a:defRPr sz="1300" b="0">
+              <a:lnSpc>
+                <a:spcPct val="115000"/>
+              </a:lnSpc>
+              <a:defRPr sz="1200" b="0">
                 <a:solidFill>
                   <a:srgbClr val="111311"/>
                 </a:solidFill>
-                <a:latin typeface="Yu Gothic"/>
               </a:defRPr>
             </a:pPr>
             <a:r>
+              <a:rPr>
+                <a:latin typeface="Meiryo"/>
+                <a:ea typeface="Meiryo"/>
+                <a:cs typeface="Meiryo"/>
+              </a:rPr>
               <a:t>志望理由と過去経験の一貫性を示せる</a:t>
             </a:r>
           </a:p>
@@ -4219,8 +4438,8 @@
         </p:nvSpPr>
         <p:spPr>
           <a:xfrm>
-            <a:off x="8229600" y="4389120"/>
-            <a:ext cx="3200400" cy="640080"/>
+            <a:off x="8321040" y="4443984"/>
+            <a:ext cx="3108960" cy="685800"/>
           </a:xfrm>
           <a:prstGeom prst="rect">
             <a:avLst/>
@@ -4228,20 +4447,27 @@
           <a:noFill/>
         </p:spPr>
         <p:txBody>
-          <a:bodyPr wrap="square">
-            <a:spAutoFit/>
+          <a:bodyPr wrap="square" lIns="0" rIns="0" anchor="t">
+            <a:noAutofit/>
           </a:bodyPr>
           <a:lstStyle/>
           <a:p>
             <a:pPr algn="l">
-              <a:defRPr sz="1200" b="0">
+              <a:lnSpc>
+                <a:spcPct val="115000"/>
+              </a:lnSpc>
+              <a:defRPr sz="1100" b="0">
                 <a:solidFill>
                   <a:srgbClr val="6B6F6B"/>
                 </a:solidFill>
-                <a:latin typeface="Yu Gothic"/>
               </a:defRPr>
             </a:pPr>
             <a:r>
+              <a:rPr>
+                <a:latin typeface="Meiryo"/>
+                <a:ea typeface="Meiryo"/>
+                <a:cs typeface="Meiryo"/>
+              </a:rPr>
               <a:t>ESに一貫性がある</a:t>
             </a:r>
           </a:p>
@@ -4255,16 +4481,18 @@
         </p:nvSpPr>
         <p:spPr>
           <a:xfrm>
-            <a:off x="548640" y="5212080"/>
-            <a:ext cx="11064240" cy="914400"/>
+            <a:off x="548640" y="5440680"/>
+            <a:ext cx="11064240" cy="777240"/>
           </a:xfrm>
           <a:prstGeom prst="roundRect">
-            <a:avLst/>
+            <a:avLst>
+              <a:gd name="adj" fmla="val 12000"/>
+            </a:avLst>
           </a:prstGeom>
           <a:solidFill>
             <a:srgbClr val="FFFFFF"/>
           </a:solidFill>
-          <a:ln w="12700">
+          <a:ln w="15875">
             <a:solidFill>
               <a:srgbClr val="E5E1D8"/>
             </a:solidFill>
@@ -4300,8 +4528,8 @@
         </p:nvSpPr>
         <p:spPr>
           <a:xfrm>
-            <a:off x="685800" y="5303520"/>
-            <a:ext cx="10789919" cy="731520"/>
+            <a:off x="731520" y="5577840"/>
+            <a:ext cx="10698480" cy="502920"/>
           </a:xfrm>
           <a:prstGeom prst="rect">
             <a:avLst/>
@@ -4309,20 +4537,27 @@
           <a:noFill/>
         </p:spPr>
         <p:txBody>
-          <a:bodyPr wrap="square">
-            <a:spAutoFit/>
+          <a:bodyPr wrap="square" lIns="0" rIns="0" anchor="t">
+            <a:noAutofit/>
           </a:bodyPr>
           <a:lstStyle/>
           <a:p>
             <a:pPr algn="ctr">
-              <a:defRPr sz="1400" b="1">
+              <a:lnSpc>
+                <a:spcPct val="115000"/>
+              </a:lnSpc>
+              <a:defRPr sz="1300" b="1">
                 <a:solidFill>
                   <a:srgbClr val="111311"/>
                 </a:solidFill>
-                <a:latin typeface="Yu Gothic"/>
               </a:defRPr>
             </a:pPr>
             <a:r>
+              <a:rPr>
+                <a:latin typeface="Meiryo"/>
+                <a:ea typeface="Meiryo"/>
+                <a:cs typeface="Meiryo"/>
+              </a:rPr>
               <a:t>目標値：就活生全員が3条件を満たして秋を迎えること</a:t>
             </a:r>
           </a:p>
@@ -4362,8 +4597,8 @@
         </p:nvSpPr>
         <p:spPr>
           <a:xfrm>
-            <a:off x="548640" y="182880"/>
-            <a:ext cx="10972800" cy="365760"/>
+            <a:off x="548640" y="228600"/>
+            <a:ext cx="11064240" cy="365760"/>
           </a:xfrm>
           <a:prstGeom prst="rect">
             <a:avLst/>
@@ -4371,20 +4606,27 @@
           <a:noFill/>
         </p:spPr>
         <p:txBody>
-          <a:bodyPr wrap="square">
-            <a:spAutoFit/>
+          <a:bodyPr wrap="square" lIns="0" rIns="0" anchor="t">
+            <a:noAutofit/>
           </a:bodyPr>
           <a:lstStyle/>
           <a:p>
             <a:pPr algn="l">
+              <a:lnSpc>
+                <a:spcPct val="115000"/>
+              </a:lnSpc>
               <a:defRPr sz="1200" b="0">
                 <a:solidFill>
                   <a:srgbClr val="6B6F6B"/>
                 </a:solidFill>
-                <a:latin typeface="Yu Gothic"/>
               </a:defRPr>
             </a:pPr>
             <a:r>
+              <a:rPr>
+                <a:latin typeface="Meiryo"/>
+                <a:ea typeface="Meiryo"/>
+                <a:cs typeface="Meiryo"/>
+              </a:rPr>
               <a:t>(02) 現状 — データが示す実態</a:t>
             </a:r>
           </a:p>
@@ -4398,8 +4640,8 @@
         </p:nvSpPr>
         <p:spPr>
           <a:xfrm>
-            <a:off x="548640" y="548640"/>
-            <a:ext cx="6400800" cy="822960"/>
+            <a:off x="548640" y="594360"/>
+            <a:ext cx="11064240" cy="822960"/>
           </a:xfrm>
           <a:prstGeom prst="rect">
             <a:avLst/>
@@ -4407,20 +4649,27 @@
           <a:noFill/>
         </p:spPr>
         <p:txBody>
-          <a:bodyPr wrap="square">
-            <a:spAutoFit/>
+          <a:bodyPr wrap="square" lIns="0" rIns="0" anchor="t">
+            <a:noAutofit/>
           </a:bodyPr>
           <a:lstStyle/>
           <a:p>
             <a:pPr algn="l">
-              <a:defRPr sz="3400" b="1">
+              <a:lnSpc>
+                <a:spcPct val="115000"/>
+              </a:lnSpc>
+              <a:defRPr sz="3000" b="1">
                 <a:solidFill>
                   <a:srgbClr val="111311"/>
                 </a:solidFill>
-                <a:latin typeface="Yu Gothic"/>
               </a:defRPr>
             </a:pPr>
             <a:r>
+              <a:rPr>
+                <a:latin typeface="Meiryo"/>
+                <a:ea typeface="Meiryo"/>
+                <a:cs typeface="Meiryo"/>
+              </a:rPr>
               <a:t>現状は未達。</a:t>
             </a:r>
           </a:p>
@@ -4435,15 +4684,17 @@
         <p:spPr>
           <a:xfrm>
             <a:off x="548640" y="1554480"/>
-            <a:ext cx="5669280" cy="4389120"/>
+            <a:ext cx="5486400" cy="4206240"/>
           </a:xfrm>
           <a:prstGeom prst="roundRect">
-            <a:avLst/>
+            <a:avLst>
+              <a:gd name="adj" fmla="val 12000"/>
+            </a:avLst>
           </a:prstGeom>
           <a:solidFill>
             <a:srgbClr val="FFFFFF"/>
           </a:solidFill>
-          <a:ln w="12700">
+          <a:ln w="15875">
             <a:solidFill>
               <a:srgbClr val="E5E1D8"/>
             </a:solidFill>
@@ -4479,8 +4730,8 @@
         </p:nvSpPr>
         <p:spPr>
           <a:xfrm>
-            <a:off x="822960" y="1737360"/>
-            <a:ext cx="5120640" cy="3931920"/>
+            <a:off x="868680" y="1783080"/>
+            <a:ext cx="4846320" cy="3657600"/>
           </a:xfrm>
           <a:prstGeom prst="rect">
             <a:avLst/>
@@ -4488,44 +4739,223 @@
           <a:noFill/>
         </p:spPr>
         <p:txBody>
-          <a:bodyPr wrap="square">
-            <a:spAutoFit/>
+          <a:bodyPr wrap="square" anchor="t">
+            <a:noAutofit/>
           </a:bodyPr>
           <a:lstStyle/>
           <a:p>
-            <a:pPr algn="l">
-              <a:defRPr sz="1300" b="0">
-                <a:solidFill>
-                  <a:srgbClr val="111311"/>
-                </a:solidFill>
-                <a:latin typeface="Yu Gothic"/>
+            <a:pPr>
+              <a:lnSpc>
+                <a:spcPct val="120000"/>
+              </a:lnSpc>
+              <a:spcAft>
+                <a:spcPts val="300"/>
+              </a:spcAft>
+              <a:defRPr sz="1300">
+                <a:solidFill>
+                  <a:srgbClr val="333333"/>
+                </a:solidFill>
               </a:defRPr>
             </a:pPr>
             <a:r>
-              <a:t>● 大変1位 自己分析 60.7%（学情 n=275）</a:t>
-            </a:r>
-            <a:br/>
-            <a:r>
-              <a:t>● ES重要1位 自己分析 42.6%（doda n=317）</a:t>
-            </a:r>
-            <a:br/>
-            <a:r>
-              <a:t>● 9月も35.2%が自己分析に逆戻り（マイナビ n=1268）</a:t>
-            </a:r>
-            <a:br/>
-            <a:r>
-              <a:t>● 信頼できる30.5%・保留42.0%（Synergy n=200）</a:t>
-            </a:r>
-            <a:br/>
-            <a:r>
-              <a:t>● 開始3年4-6月は35%のみ（doda n=239）</a:t>
-            </a:r>
+              <a:rPr>
+                <a:latin typeface="Meiryo"/>
+                <a:ea typeface="Meiryo"/>
+                <a:cs typeface="Meiryo"/>
+              </a:rPr>
+              <a:t>● 大変1位 自己分析 60.7%</a:t>
+            </a:r>
+          </a:p>
+          <a:p>
+            <a:pPr>
+              <a:lnSpc>
+                <a:spcPct val="120000"/>
+              </a:lnSpc>
+              <a:spcAft>
+                <a:spcPts val="300"/>
+              </a:spcAft>
+              <a:defRPr sz="1300">
+                <a:solidFill>
+                  <a:srgbClr val="333333"/>
+                </a:solidFill>
+              </a:defRPr>
+            </a:pPr>
+            <a:r>
+              <a:rPr>
+                <a:latin typeface="Meiryo"/>
+                <a:ea typeface="Meiryo"/>
+                <a:cs typeface="Meiryo"/>
+              </a:rPr>
+              <a:t>　学情 26卒 n=275</a:t>
+            </a:r>
+          </a:p>
+          <a:p>
+            <a:pPr>
+              <a:lnSpc>
+                <a:spcPct val="120000"/>
+              </a:lnSpc>
+              <a:spcAft>
+                <a:spcPts val="300"/>
+              </a:spcAft>
+              <a:defRPr sz="1300">
+                <a:solidFill>
+                  <a:srgbClr val="333333"/>
+                </a:solidFill>
+              </a:defRPr>
+            </a:pPr>
+            <a:r>
+              <a:rPr>
+                <a:latin typeface="Meiryo"/>
+                <a:ea typeface="Meiryo"/>
+                <a:cs typeface="Meiryo"/>
+              </a:rPr>
+              <a:t>● ES重要1位 42.6%</a:t>
+            </a:r>
+          </a:p>
+          <a:p>
+            <a:pPr>
+              <a:lnSpc>
+                <a:spcPct val="120000"/>
+              </a:lnSpc>
+              <a:spcAft>
+                <a:spcPts val="300"/>
+              </a:spcAft>
+              <a:defRPr sz="1300">
+                <a:solidFill>
+                  <a:srgbClr val="333333"/>
+                </a:solidFill>
+              </a:defRPr>
+            </a:pPr>
+            <a:r>
+              <a:rPr>
+                <a:latin typeface="Meiryo"/>
+                <a:ea typeface="Meiryo"/>
+                <a:cs typeface="Meiryo"/>
+              </a:rPr>
+              <a:t>　doda n=317</a:t>
+            </a:r>
+          </a:p>
+          <a:p>
+            <a:pPr>
+              <a:lnSpc>
+                <a:spcPct val="120000"/>
+              </a:lnSpc>
+              <a:spcAft>
+                <a:spcPts val="300"/>
+              </a:spcAft>
+              <a:defRPr sz="1300">
+                <a:solidFill>
+                  <a:srgbClr val="333333"/>
+                </a:solidFill>
+              </a:defRPr>
+            </a:pPr>
+            <a:r>
+              <a:rPr>
+                <a:latin typeface="Meiryo"/>
+                <a:ea typeface="Meiryo"/>
+                <a:cs typeface="Meiryo"/>
+              </a:rPr>
+              <a:t>● 9月も35.2%が逆戻り</a:t>
+            </a:r>
+          </a:p>
+          <a:p>
+            <a:pPr>
+              <a:lnSpc>
+                <a:spcPct val="120000"/>
+              </a:lnSpc>
+              <a:spcAft>
+                <a:spcPts val="300"/>
+              </a:spcAft>
+              <a:defRPr sz="1300">
+                <a:solidFill>
+                  <a:srgbClr val="333333"/>
+                </a:solidFill>
+              </a:defRPr>
+            </a:pPr>
+            <a:r>
+              <a:rPr>
+                <a:latin typeface="Meiryo"/>
+                <a:ea typeface="Meiryo"/>
+                <a:cs typeface="Meiryo"/>
+              </a:rPr>
+              <a:t>　マイナビ n=1268</a:t>
+            </a:r>
+          </a:p>
+          <a:p>
+            <a:pPr>
+              <a:lnSpc>
+                <a:spcPct val="120000"/>
+              </a:lnSpc>
+              <a:spcAft>
+                <a:spcPts val="300"/>
+              </a:spcAft>
+              <a:defRPr sz="1300">
+                <a:solidFill>
+                  <a:srgbClr val="333333"/>
+                </a:solidFill>
+              </a:defRPr>
+            </a:pPr>
+            <a:r>
+              <a:rPr>
+                <a:latin typeface="Meiryo"/>
+                <a:ea typeface="Meiryo"/>
+                <a:cs typeface="Meiryo"/>
+              </a:rPr>
+              <a:t>● 信頼30.5%・保留42.0%</a:t>
+            </a:r>
+          </a:p>
+        </p:txBody>
+      </p:sp>
+      <p:sp>
+        <p:nvSpPr>
+          <p:cNvPr id="6" name="Rounded Rectangle 5"/>
+          <p:cNvSpPr/>
+          <p:nvPr/>
+        </p:nvSpPr>
+        <p:spPr>
+          <a:xfrm>
+            <a:off x="6217920" y="1554480"/>
+            <a:ext cx="5394960" cy="4206240"/>
+          </a:xfrm>
+          <a:prstGeom prst="roundRect">
+            <a:avLst>
+              <a:gd name="adj" fmla="val 12000"/>
+            </a:avLst>
+          </a:prstGeom>
+          <a:solidFill>
+            <a:srgbClr val="FFFFFF"/>
+          </a:solidFill>
+          <a:ln w="15875">
+            <a:solidFill>
+              <a:srgbClr val="E5E1D8"/>
+            </a:solidFill>
+          </a:ln>
+        </p:spPr>
+        <p:style>
+          <a:lnRef idx="1">
+            <a:schemeClr val="accent1"/>
+          </a:lnRef>
+          <a:fillRef idx="3">
+            <a:schemeClr val="accent1"/>
+          </a:fillRef>
+          <a:effectRef idx="2">
+            <a:schemeClr val="accent1"/>
+          </a:effectRef>
+          <a:fontRef idx="minor">
+            <a:schemeClr val="lt1"/>
+          </a:fontRef>
+        </p:style>
+        <p:txBody>
+          <a:bodyPr rtlCol="0" anchor="ctr"/>
+          <a:lstStyle/>
+          <a:p>
+            <a:pPr algn="ctr"/>
           </a:p>
         </p:txBody>
       </p:sp>
       <p:pic>
         <p:nvPicPr>
-          <p:cNvPr id="6" name="Picture 5" descr="gakujo_taihen.png"/>
+          <p:cNvPr id="7" name="Picture 6" descr="gakujo_taihen.png"/>
           <p:cNvPicPr>
             <a:picLocks noChangeAspect="1"/>
           </p:cNvPicPr>
@@ -4539,8 +4969,8 @@
         </p:blipFill>
         <p:spPr>
           <a:xfrm>
-            <a:off x="6492240" y="1554480"/>
-            <a:ext cx="5120640" cy="2926080"/>
+            <a:off x="6400800" y="1737360"/>
+            <a:ext cx="5029200" cy="2873829"/>
           </a:xfrm>
           <a:prstGeom prst="rect">
             <a:avLst/>
@@ -4549,14 +4979,14 @@
       </p:pic>
       <p:sp>
         <p:nvSpPr>
-          <p:cNvPr id="7" name="TextBox 6"/>
+          <p:cNvPr id="8" name="TextBox 7"/>
           <p:cNvSpPr txBox="1"/>
           <p:nvPr/>
         </p:nvSpPr>
         <p:spPr>
           <a:xfrm>
-            <a:off x="6492240" y="4663440"/>
-            <a:ext cx="5120640" cy="1097280"/>
+            <a:off x="6400800" y="4892040"/>
+            <a:ext cx="5029200" cy="548640"/>
           </a:xfrm>
           <a:prstGeom prst="rect">
             <a:avLst/>
@@ -4564,35 +4994,42 @@
           <a:noFill/>
         </p:spPr>
         <p:txBody>
-          <a:bodyPr wrap="square">
-            <a:spAutoFit/>
+          <a:bodyPr wrap="square" lIns="0" rIns="0" anchor="t">
+            <a:noAutofit/>
           </a:bodyPr>
           <a:lstStyle/>
           <a:p>
             <a:pPr algn="ctr">
-              <a:defRPr sz="1300" b="1">
+              <a:lnSpc>
+                <a:spcPct val="115000"/>
+              </a:lnSpc>
+              <a:defRPr sz="1200" b="1">
                 <a:solidFill>
                   <a:srgbClr val="B91C1C"/>
                 </a:solidFill>
-                <a:latin typeface="Yu Gothic"/>
               </a:defRPr>
             </a:pPr>
             <a:r>
-              <a:t>→ 6割が苦戦・3割超が秋に手戻り＝土台未完成</a:t>
-            </a:r>
-          </a:p>
-        </p:txBody>
-      </p:sp>
-      <p:sp>
-        <p:nvSpPr>
-          <p:cNvPr id="8" name="TextBox 7"/>
+              <a:rPr>
+                <a:latin typeface="Meiryo"/>
+                <a:ea typeface="Meiryo"/>
+                <a:cs typeface="Meiryo"/>
+              </a:rPr>
+              <a:t>→ 6割が苦戦・3割超が手戻り</a:t>
+            </a:r>
+          </a:p>
+        </p:txBody>
+      </p:sp>
+      <p:sp>
+        <p:nvSpPr>
+          <p:cNvPr id="9" name="TextBox 8"/>
           <p:cNvSpPr txBox="1"/>
           <p:nvPr/>
         </p:nvSpPr>
         <p:spPr>
           <a:xfrm>
-            <a:off x="548640" y="6126480"/>
-            <a:ext cx="10972800" cy="365760"/>
+            <a:off x="548640" y="6035040"/>
+            <a:ext cx="11064240" cy="365760"/>
           </a:xfrm>
           <a:prstGeom prst="rect">
             <a:avLst/>
@@ -4600,20 +5037,27 @@
           <a:noFill/>
         </p:spPr>
         <p:txBody>
-          <a:bodyPr wrap="square">
-            <a:spAutoFit/>
+          <a:bodyPr wrap="square" lIns="0" rIns="0" anchor="t">
+            <a:noAutofit/>
           </a:bodyPr>
           <a:lstStyle/>
           <a:p>
             <a:pPr algn="l">
+              <a:lnSpc>
+                <a:spcPct val="115000"/>
+              </a:lnSpc>
               <a:defRPr sz="1000" b="0">
                 <a:solidFill>
                   <a:srgbClr val="6B6F6B"/>
                 </a:solidFill>
-                <a:latin typeface="Yu Gothic"/>
               </a:defRPr>
             </a:pPr>
             <a:r>
+              <a:rPr>
+                <a:latin typeface="Meiryo"/>
+                <a:ea typeface="Meiryo"/>
+                <a:cs typeface="Meiryo"/>
+              </a:rPr>
               <a:t>出典：Webデータ集にリンク集約</a:t>
             </a:r>
           </a:p>
@@ -4653,8 +5097,8 @@
         </p:nvSpPr>
         <p:spPr>
           <a:xfrm>
-            <a:off x="548640" y="182880"/>
-            <a:ext cx="10972800" cy="365760"/>
+            <a:off x="548640" y="228600"/>
+            <a:ext cx="11064240" cy="365760"/>
           </a:xfrm>
           <a:prstGeom prst="rect">
             <a:avLst/>
@@ -4662,20 +5106,27 @@
           <a:noFill/>
         </p:spPr>
         <p:txBody>
-          <a:bodyPr wrap="square">
-            <a:spAutoFit/>
+          <a:bodyPr wrap="square" lIns="0" rIns="0" anchor="t">
+            <a:noAutofit/>
           </a:bodyPr>
           <a:lstStyle/>
           <a:p>
             <a:pPr algn="l">
+              <a:lnSpc>
+                <a:spcPct val="115000"/>
+              </a:lnSpc>
               <a:defRPr sz="1200" b="0">
                 <a:solidFill>
                   <a:srgbClr val="6B6F6B"/>
                 </a:solidFill>
-                <a:latin typeface="Yu Gothic"/>
               </a:defRPr>
             </a:pPr>
             <a:r>
+              <a:rPr>
+                <a:latin typeface="Meiryo"/>
+                <a:ea typeface="Meiryo"/>
+                <a:cs typeface="Meiryo"/>
+              </a:rPr>
               <a:t>(03) 課題設定 — ゴール − 現状 ＝ 課題</a:t>
             </a:r>
           </a:p>
@@ -4689,8 +5140,8 @@
         </p:nvSpPr>
         <p:spPr>
           <a:xfrm>
-            <a:off x="548640" y="548640"/>
-            <a:ext cx="10972800" cy="731520"/>
+            <a:off x="548640" y="594360"/>
+            <a:ext cx="11064240" cy="731520"/>
           </a:xfrm>
           <a:prstGeom prst="rect">
             <a:avLst/>
@@ -4698,20 +5149,27 @@
           <a:noFill/>
         </p:spPr>
         <p:txBody>
-          <a:bodyPr wrap="square">
-            <a:spAutoFit/>
+          <a:bodyPr wrap="square" lIns="0" rIns="0" anchor="t">
+            <a:noAutofit/>
           </a:bodyPr>
           <a:lstStyle/>
           <a:p>
             <a:pPr algn="l">
-              <a:defRPr sz="3400" b="1">
+              <a:lnSpc>
+                <a:spcPct val="115000"/>
+              </a:lnSpc>
+              <a:defRPr sz="3000" b="1">
                 <a:solidFill>
                   <a:srgbClr val="111311"/>
                 </a:solidFill>
-                <a:latin typeface="Yu Gothic"/>
               </a:defRPr>
             </a:pPr>
             <a:r>
+              <a:rPr>
+                <a:latin typeface="Meiryo"/>
+                <a:ea typeface="Meiryo"/>
+                <a:cs typeface="Meiryo"/>
+              </a:rPr>
               <a:t>式で定義する。</a:t>
             </a:r>
           </a:p>
@@ -4725,16 +5183,18 @@
         </p:nvSpPr>
         <p:spPr>
           <a:xfrm>
-            <a:off x="548640" y="1554480"/>
-            <a:ext cx="3291840" cy="1645920"/>
+            <a:off x="548640" y="1508760"/>
+            <a:ext cx="3200400" cy="1554480"/>
           </a:xfrm>
           <a:prstGeom prst="roundRect">
-            <a:avLst/>
+            <a:avLst>
+              <a:gd name="adj" fmla="val 12000"/>
+            </a:avLst>
           </a:prstGeom>
           <a:solidFill>
             <a:srgbClr val="FFFFFF"/>
           </a:solidFill>
-          <a:ln w="12700">
+          <a:ln w="15875">
             <a:solidFill>
               <a:srgbClr val="E5E1D8"/>
             </a:solidFill>
@@ -4770,8 +5230,8 @@
         </p:nvSpPr>
         <p:spPr>
           <a:xfrm>
-            <a:off x="685800" y="1645920"/>
-            <a:ext cx="3017520" cy="1463040"/>
+            <a:off x="731520" y="1645919"/>
+            <a:ext cx="2834640" cy="1280160"/>
           </a:xfrm>
           <a:prstGeom prst="rect">
             <a:avLst/>
@@ -4779,24 +5239,36 @@
           <a:noFill/>
         </p:spPr>
         <p:txBody>
-          <a:bodyPr wrap="square">
-            <a:spAutoFit/>
+          <a:bodyPr wrap="square" lIns="0" rIns="0" anchor="t">
+            <a:noAutofit/>
           </a:bodyPr>
           <a:lstStyle/>
           <a:p>
             <a:pPr algn="ctr">
-              <a:defRPr sz="1500" b="1">
+              <a:lnSpc>
+                <a:spcPct val="115000"/>
+              </a:lnSpc>
+              <a:defRPr sz="1300" b="1">
                 <a:solidFill>
                   <a:srgbClr val="111311"/>
                 </a:solidFill>
-                <a:latin typeface="Yu Gothic"/>
               </a:defRPr>
             </a:pPr>
             <a:r>
+              <a:rPr>
+                <a:latin typeface="Meiryo"/>
+                <a:ea typeface="Meiryo"/>
+                <a:cs typeface="Meiryo"/>
+              </a:rPr>
               <a:t>ゴール</a:t>
             </a:r>
             <a:br/>
             <a:r>
+              <a:rPr>
+                <a:latin typeface="Meiryo"/>
+                <a:ea typeface="Meiryo"/>
+                <a:cs typeface="Meiryo"/>
+              </a:rPr>
               <a:t>3条件を満たす</a:t>
             </a:r>
           </a:p>
@@ -4810,8 +5282,8 @@
         </p:nvSpPr>
         <p:spPr>
           <a:xfrm>
-            <a:off x="3931920" y="2011680"/>
-            <a:ext cx="457200" cy="731520"/>
+            <a:off x="3794760" y="1874519"/>
+            <a:ext cx="502920" cy="731520"/>
           </a:xfrm>
           <a:prstGeom prst="rect">
             <a:avLst/>
@@ -4819,20 +5291,27 @@
           <a:noFill/>
         </p:spPr>
         <p:txBody>
-          <a:bodyPr wrap="square">
-            <a:spAutoFit/>
+          <a:bodyPr wrap="square" lIns="0" rIns="0" anchor="t">
+            <a:noAutofit/>
           </a:bodyPr>
           <a:lstStyle/>
           <a:p>
             <a:pPr algn="ctr">
-              <a:defRPr sz="3000" b="1">
+              <a:lnSpc>
+                <a:spcPct val="115000"/>
+              </a:lnSpc>
+              <a:defRPr sz="2800" b="1">
                 <a:solidFill>
                   <a:srgbClr val="111311"/>
                 </a:solidFill>
-                <a:latin typeface="Yu Gothic"/>
               </a:defRPr>
             </a:pPr>
             <a:r>
+              <a:rPr>
+                <a:latin typeface="Meiryo"/>
+                <a:ea typeface="Meiryo"/>
+                <a:cs typeface="Meiryo"/>
+              </a:rPr>
               <a:t>−</a:t>
             </a:r>
           </a:p>
@@ -4846,16 +5325,18 @@
         </p:nvSpPr>
         <p:spPr>
           <a:xfrm>
-            <a:off x="4480560" y="1554480"/>
-            <a:ext cx="3291840" cy="1645920"/>
+            <a:off x="4389120" y="1508760"/>
+            <a:ext cx="3200400" cy="1554480"/>
           </a:xfrm>
           <a:prstGeom prst="roundRect">
-            <a:avLst/>
+            <a:avLst>
+              <a:gd name="adj" fmla="val 12000"/>
+            </a:avLst>
           </a:prstGeom>
           <a:solidFill>
             <a:srgbClr val="FFFFFF"/>
           </a:solidFill>
-          <a:ln w="12700">
+          <a:ln w="15875">
             <a:solidFill>
               <a:srgbClr val="E5E1D8"/>
             </a:solidFill>
@@ -4891,8 +5372,8 @@
         </p:nvSpPr>
         <p:spPr>
           <a:xfrm>
-            <a:off x="4617720" y="1645920"/>
-            <a:ext cx="3017520" cy="1463040"/>
+            <a:off x="4572000" y="1645919"/>
+            <a:ext cx="2834640" cy="1280160"/>
           </a:xfrm>
           <a:prstGeom prst="rect">
             <a:avLst/>
@@ -4900,28 +5381,45 @@
           <a:noFill/>
         </p:spPr>
         <p:txBody>
-          <a:bodyPr wrap="square">
-            <a:spAutoFit/>
+          <a:bodyPr wrap="square" lIns="0" rIns="0" anchor="t">
+            <a:noAutofit/>
           </a:bodyPr>
           <a:lstStyle/>
           <a:p>
             <a:pPr algn="ctr">
-              <a:defRPr sz="1400" b="1">
+              <a:lnSpc>
+                <a:spcPct val="115000"/>
+              </a:lnSpc>
+              <a:defRPr sz="1300" b="1">
                 <a:solidFill>
                   <a:srgbClr val="111311"/>
                 </a:solidFill>
-                <a:latin typeface="Yu Gothic"/>
               </a:defRPr>
             </a:pPr>
             <a:r>
+              <a:rPr>
+                <a:latin typeface="Meiryo"/>
+                <a:ea typeface="Meiryo"/>
+                <a:cs typeface="Meiryo"/>
+              </a:rPr>
               <a:t>現状</a:t>
             </a:r>
             <a:br/>
             <a:r>
+              <a:rPr>
+                <a:latin typeface="Meiryo"/>
+                <a:ea typeface="Meiryo"/>
+                <a:cs typeface="Meiryo"/>
+              </a:rPr>
               <a:t>60.7%が苦戦</a:t>
             </a:r>
             <a:br/>
             <a:r>
+              <a:rPr>
+                <a:latin typeface="Meiryo"/>
+                <a:ea typeface="Meiryo"/>
+                <a:cs typeface="Meiryo"/>
+              </a:rPr>
               <a:t>35.2%が手戻り</a:t>
             </a:r>
           </a:p>
@@ -4935,8 +5433,8 @@
         </p:nvSpPr>
         <p:spPr>
           <a:xfrm>
-            <a:off x="7863840" y="2011680"/>
-            <a:ext cx="457200" cy="731520"/>
+            <a:off x="7635240" y="1874519"/>
+            <a:ext cx="502920" cy="731520"/>
           </a:xfrm>
           <a:prstGeom prst="rect">
             <a:avLst/>
@@ -4944,20 +5442,27 @@
           <a:noFill/>
         </p:spPr>
         <p:txBody>
-          <a:bodyPr wrap="square">
-            <a:spAutoFit/>
+          <a:bodyPr wrap="square" lIns="0" rIns="0" anchor="t">
+            <a:noAutofit/>
           </a:bodyPr>
           <a:lstStyle/>
           <a:p>
             <a:pPr algn="ctr">
-              <a:defRPr sz="3000" b="1">
+              <a:lnSpc>
+                <a:spcPct val="115000"/>
+              </a:lnSpc>
+              <a:defRPr sz="2800" b="1">
                 <a:solidFill>
                   <a:srgbClr val="111311"/>
                 </a:solidFill>
-                <a:latin typeface="Yu Gothic"/>
               </a:defRPr>
             </a:pPr>
             <a:r>
+              <a:rPr>
+                <a:latin typeface="Meiryo"/>
+                <a:ea typeface="Meiryo"/>
+                <a:cs typeface="Meiryo"/>
+              </a:rPr>
               <a:t>＝</a:t>
             </a:r>
           </a:p>
@@ -4971,16 +5476,18 @@
         </p:nvSpPr>
         <p:spPr>
           <a:xfrm>
-            <a:off x="8412480" y="1554480"/>
-            <a:ext cx="3200400" cy="1645920"/>
+            <a:off x="8229600" y="1508760"/>
+            <a:ext cx="3383280" cy="1554480"/>
           </a:xfrm>
           <a:prstGeom prst="roundRect">
-            <a:avLst/>
+            <a:avLst>
+              <a:gd name="adj" fmla="val 12000"/>
+            </a:avLst>
           </a:prstGeom>
           <a:solidFill>
-            <a:srgbClr val="B91C1C"/>
+            <a:srgbClr val="FFFFFF"/>
           </a:solidFill>
-          <a:ln w="12700">
+          <a:ln w="15875">
             <a:solidFill>
               <a:srgbClr val="B91C1C"/>
             </a:solidFill>
@@ -5016,8 +5523,8 @@
         </p:nvSpPr>
         <p:spPr>
           <a:xfrm>
-            <a:off x="8549640" y="1645920"/>
-            <a:ext cx="2926080" cy="1463040"/>
+            <a:off x="8412480" y="1645919"/>
+            <a:ext cx="3017520" cy="1280160"/>
           </a:xfrm>
           <a:prstGeom prst="rect">
             <a:avLst/>
@@ -5025,20 +5532,27 @@
           <a:noFill/>
         </p:spPr>
         <p:txBody>
-          <a:bodyPr wrap="square">
-            <a:spAutoFit/>
+          <a:bodyPr wrap="square" lIns="0" rIns="0" anchor="t">
+            <a:noAutofit/>
           </a:bodyPr>
           <a:lstStyle/>
           <a:p>
             <a:pPr algn="ctr">
-              <a:defRPr sz="1500" b="1">
+              <a:lnSpc>
+                <a:spcPct val="115000"/>
+              </a:lnSpc>
+              <a:defRPr sz="1400" b="1">
                 <a:solidFill>
                   <a:srgbClr val="B91C1C"/>
                 </a:solidFill>
-                <a:latin typeface="Yu Gothic"/>
               </a:defRPr>
             </a:pPr>
             <a:r>
+              <a:rPr>
+                <a:latin typeface="Meiryo"/>
+                <a:ea typeface="Meiryo"/>
+                <a:cs typeface="Meiryo"/>
+              </a:rPr>
               <a:t>課題</a:t>
             </a:r>
           </a:p>
@@ -5052,16 +5566,18 @@
         </p:nvSpPr>
         <p:spPr>
           <a:xfrm>
-            <a:off x="548640" y="3566160"/>
-            <a:ext cx="11064240" cy="2011680"/>
+            <a:off x="548640" y="3337560"/>
+            <a:ext cx="11064240" cy="1828800"/>
           </a:xfrm>
           <a:prstGeom prst="roundRect">
-            <a:avLst/>
+            <a:avLst>
+              <a:gd name="adj" fmla="val 12000"/>
+            </a:avLst>
           </a:prstGeom>
           <a:solidFill>
             <a:srgbClr val="FFFFFF"/>
           </a:solidFill>
-          <a:ln w="12700">
+          <a:ln w="15875">
             <a:solidFill>
               <a:srgbClr val="B91C1C"/>
             </a:solidFill>
@@ -5097,8 +5613,8 @@
         </p:nvSpPr>
         <p:spPr>
           <a:xfrm>
-            <a:off x="914400" y="3749039"/>
-            <a:ext cx="10332720" cy="1645920"/>
+            <a:off x="1005840" y="3566160"/>
+            <a:ext cx="10149840" cy="1371600"/>
           </a:xfrm>
           <a:prstGeom prst="rect">
             <a:avLst/>
@@ -5106,20 +5622,27 @@
           <a:noFill/>
         </p:spPr>
         <p:txBody>
-          <a:bodyPr wrap="square">
-            <a:spAutoFit/>
+          <a:bodyPr wrap="square" lIns="0" rIns="0" anchor="t">
+            <a:noAutofit/>
           </a:bodyPr>
           <a:lstStyle/>
           <a:p>
             <a:pPr algn="ctr">
-              <a:defRPr sz="1800" b="1">
+              <a:lnSpc>
+                <a:spcPct val="115000"/>
+              </a:lnSpc>
+              <a:defRPr sz="1600" b="1">
                 <a:solidFill>
                   <a:srgbClr val="B91C1C"/>
                 </a:solidFill>
-                <a:latin typeface="Yu Gothic"/>
               </a:defRPr>
             </a:pPr>
             <a:r>
+              <a:rPr>
+                <a:latin typeface="Meiryo"/>
+                <a:ea typeface="Meiryo"/>
+                <a:cs typeface="Meiryo"/>
+              </a:rPr>
               <a:t>やり方とゴールが分からないために、6割が苦戦したまま選考に進んでしまうこと</a:t>
             </a:r>
           </a:p>
@@ -5133,8 +5656,8 @@
         </p:nvSpPr>
         <p:spPr>
           <a:xfrm>
-            <a:off x="548640" y="5852160"/>
-            <a:ext cx="10972800" cy="365760"/>
+            <a:off x="548640" y="5440680"/>
+            <a:ext cx="11064240" cy="548640"/>
           </a:xfrm>
           <a:prstGeom prst="rect">
             <a:avLst/>
@@ -5142,20 +5665,27 @@
           <a:noFill/>
         </p:spPr>
         <p:txBody>
-          <a:bodyPr wrap="square">
-            <a:spAutoFit/>
+          <a:bodyPr wrap="square" lIns="0" rIns="0" anchor="t">
+            <a:noAutofit/>
           </a:bodyPr>
           <a:lstStyle/>
           <a:p>
             <a:pPr algn="ctr">
-              <a:defRPr sz="1200" b="0">
+              <a:lnSpc>
+                <a:spcPct val="115000"/>
+              </a:lnSpc>
+              <a:defRPr sz="1100" b="0">
                 <a:solidFill>
                   <a:srgbClr val="6B6F6B"/>
                 </a:solidFill>
-                <a:latin typeface="Yu Gothic"/>
               </a:defRPr>
             </a:pPr>
             <a:r>
+              <a:rPr>
+                <a:latin typeface="Meiryo"/>
+                <a:ea typeface="Meiryo"/>
+                <a:cs typeface="Meiryo"/>
+              </a:rPr>
               <a:t>読み上げ：十分な自己理解で挑むべきなのに、手順もゴールもなく、自信なきまま始めるしかない。</a:t>
             </a:r>
           </a:p>
@@ -5195,8 +5725,8 @@
         </p:nvSpPr>
         <p:spPr>
           <a:xfrm>
-            <a:off x="548640" y="182880"/>
-            <a:ext cx="10972800" cy="365760"/>
+            <a:off x="548640" y="228600"/>
+            <a:ext cx="11064240" cy="365760"/>
           </a:xfrm>
           <a:prstGeom prst="rect">
             <a:avLst/>
@@ -5204,20 +5734,27 @@
           <a:noFill/>
         </p:spPr>
         <p:txBody>
-          <a:bodyPr wrap="square">
-            <a:spAutoFit/>
+          <a:bodyPr wrap="square" lIns="0" rIns="0" anchor="t">
+            <a:noAutofit/>
           </a:bodyPr>
           <a:lstStyle/>
           <a:p>
             <a:pPr algn="l">
+              <a:lnSpc>
+                <a:spcPct val="115000"/>
+              </a:lnSpc>
               <a:defRPr sz="1200" b="0">
                 <a:solidFill>
                   <a:srgbClr val="6B6F6B"/>
                 </a:solidFill>
-                <a:latin typeface="Yu Gothic"/>
               </a:defRPr>
             </a:pPr>
             <a:r>
+              <a:rPr>
+                <a:latin typeface="Meiryo"/>
+                <a:ea typeface="Meiryo"/>
+                <a:cs typeface="Meiryo"/>
+              </a:rPr>
               <a:t>(04) 課題分析① — なぜ起きるか（原因3分解）</a:t>
             </a:r>
           </a:p>
@@ -5231,8 +5768,8 @@
         </p:nvSpPr>
         <p:spPr>
           <a:xfrm>
-            <a:off x="548640" y="548640"/>
-            <a:ext cx="10972800" cy="731520"/>
+            <a:off x="548640" y="594360"/>
+            <a:ext cx="11064240" cy="731520"/>
           </a:xfrm>
           <a:prstGeom prst="rect">
             <a:avLst/>
@@ -5240,20 +5777,27 @@
           <a:noFill/>
         </p:spPr>
         <p:txBody>
-          <a:bodyPr wrap="square">
-            <a:spAutoFit/>
+          <a:bodyPr wrap="square" lIns="0" rIns="0" anchor="t">
+            <a:noAutofit/>
           </a:bodyPr>
           <a:lstStyle/>
           <a:p>
             <a:pPr algn="l">
-              <a:defRPr sz="3400" b="1">
+              <a:lnSpc>
+                <a:spcPct val="115000"/>
+              </a:lnSpc>
+              <a:defRPr sz="3000" b="1">
                 <a:solidFill>
                   <a:srgbClr val="111311"/>
                 </a:solidFill>
-                <a:latin typeface="Yu Gothic"/>
               </a:defRPr>
             </a:pPr>
             <a:r>
+              <a:rPr>
+                <a:latin typeface="Meiryo"/>
+                <a:ea typeface="Meiryo"/>
+                <a:cs typeface="Meiryo"/>
+              </a:rPr>
               <a:t>原因は3つ。</a:t>
             </a:r>
           </a:p>
@@ -5267,16 +5811,18 @@
         </p:nvSpPr>
         <p:spPr>
           <a:xfrm>
-            <a:off x="548640" y="1554480"/>
-            <a:ext cx="3566160" cy="3108960"/>
+            <a:off x="548640" y="1508760"/>
+            <a:ext cx="3566160" cy="3017520"/>
           </a:xfrm>
           <a:prstGeom prst="roundRect">
-            <a:avLst/>
+            <a:avLst>
+              <a:gd name="adj" fmla="val 12000"/>
+            </a:avLst>
           </a:prstGeom>
           <a:solidFill>
             <a:srgbClr val="FFFFFF"/>
           </a:solidFill>
-          <a:ln w="12700">
+          <a:ln w="15875">
             <a:solidFill>
               <a:srgbClr val="E5E1D8"/>
             </a:solidFill>
@@ -5312,8 +5858,8 @@
         </p:nvSpPr>
         <p:spPr>
           <a:xfrm>
-            <a:off x="731520" y="1737360"/>
-            <a:ext cx="3200400" cy="457200"/>
+            <a:off x="777240" y="1737360"/>
+            <a:ext cx="3108960" cy="457200"/>
           </a:xfrm>
           <a:prstGeom prst="rect">
             <a:avLst/>
@@ -5321,20 +5867,27 @@
           <a:noFill/>
         </p:spPr>
         <p:txBody>
-          <a:bodyPr wrap="square">
-            <a:spAutoFit/>
+          <a:bodyPr wrap="square" lIns="0" rIns="0" anchor="t">
+            <a:noAutofit/>
           </a:bodyPr>
           <a:lstStyle/>
           <a:p>
             <a:pPr algn="ctr">
-              <a:defRPr sz="1400" b="1">
+              <a:lnSpc>
+                <a:spcPct val="115000"/>
+              </a:lnSpc>
+              <a:defRPr sz="1300" b="1">
                 <a:solidFill>
                   <a:srgbClr val="111311"/>
                 </a:solidFill>
-                <a:latin typeface="Yu Gothic"/>
               </a:defRPr>
             </a:pPr>
             <a:r>
+              <a:rPr>
+                <a:latin typeface="Meiryo"/>
+                <a:ea typeface="Meiryo"/>
+                <a:cs typeface="Meiryo"/>
+              </a:rPr>
               <a:t>原因A：手順不明</a:t>
             </a:r>
           </a:p>
@@ -5348,8 +5901,8 @@
         </p:nvSpPr>
         <p:spPr>
           <a:xfrm>
-            <a:off x="731520" y="2468880"/>
-            <a:ext cx="3200400" cy="1463040"/>
+            <a:off x="777240" y="2377440"/>
+            <a:ext cx="3108960" cy="1463040"/>
           </a:xfrm>
           <a:prstGeom prst="rect">
             <a:avLst/>
@@ -5357,24 +5910,36 @@
           <a:noFill/>
         </p:spPr>
         <p:txBody>
-          <a:bodyPr wrap="square">
-            <a:spAutoFit/>
+          <a:bodyPr wrap="square" lIns="0" rIns="0" anchor="t">
+            <a:noAutofit/>
           </a:bodyPr>
           <a:lstStyle/>
           <a:p>
             <a:pPr algn="ctr">
-              <a:defRPr sz="1300" b="0">
+              <a:lnSpc>
+                <a:spcPct val="115000"/>
+              </a:lnSpc>
+              <a:defRPr sz="1200" b="0">
                 <a:solidFill>
                   <a:srgbClr val="333333"/>
                 </a:solidFill>
-                <a:latin typeface="Yu Gothic"/>
               </a:defRPr>
             </a:pPr>
             <a:r>
+              <a:rPr>
+                <a:latin typeface="Meiryo"/>
+                <a:ea typeface="Meiryo"/>
+                <a:cs typeface="Meiryo"/>
+              </a:rPr>
               <a:t>53%は診断を試すも</a:t>
             </a:r>
             <a:br/>
             <a:r>
+              <a:rPr>
+                <a:latin typeface="Meiryo"/>
+                <a:ea typeface="Meiryo"/>
+                <a:cs typeface="Meiryo"/>
+              </a:rPr>
               <a:t>職種と結びつかない</a:t>
             </a:r>
           </a:p>
@@ -5388,8 +5953,8 @@
         </p:nvSpPr>
         <p:spPr>
           <a:xfrm>
-            <a:off x="2011680" y="4754880"/>
-            <a:ext cx="640080" cy="457200"/>
+            <a:off x="2103120" y="4617720"/>
+            <a:ext cx="457200" cy="457200"/>
           </a:xfrm>
           <a:prstGeom prst="rect">
             <a:avLst/>
@@ -5397,20 +5962,27 @@
           <a:noFill/>
         </p:spPr>
         <p:txBody>
-          <a:bodyPr wrap="square">
-            <a:spAutoFit/>
+          <a:bodyPr wrap="square" lIns="0" rIns="0" anchor="t">
+            <a:noAutofit/>
           </a:bodyPr>
           <a:lstStyle/>
           <a:p>
             <a:pPr algn="ctr">
-              <a:defRPr sz="1600" b="1">
+              <a:lnSpc>
+                <a:spcPct val="115000"/>
+              </a:lnSpc>
+              <a:defRPr sz="1400" b="1">
                 <a:solidFill>
                   <a:srgbClr val="B91C1C"/>
                 </a:solidFill>
-                <a:latin typeface="Yu Gothic"/>
               </a:defRPr>
             </a:pPr>
             <a:r>
+              <a:rPr>
+                <a:latin typeface="Meiryo"/>
+                <a:ea typeface="Meiryo"/>
+                <a:cs typeface="Meiryo"/>
+              </a:rPr>
               <a:t>▼</a:t>
             </a:r>
           </a:p>
@@ -5424,16 +5996,18 @@
         </p:nvSpPr>
         <p:spPr>
           <a:xfrm>
-            <a:off x="4297679" y="1554480"/>
-            <a:ext cx="3566160" cy="3108960"/>
+            <a:off x="4297679" y="1508760"/>
+            <a:ext cx="3566160" cy="3017520"/>
           </a:xfrm>
           <a:prstGeom prst="roundRect">
-            <a:avLst/>
+            <a:avLst>
+              <a:gd name="adj" fmla="val 12000"/>
+            </a:avLst>
           </a:prstGeom>
           <a:solidFill>
             <a:srgbClr val="FFFFFF"/>
           </a:solidFill>
-          <a:ln w="12700">
+          <a:ln w="15875">
             <a:solidFill>
               <a:srgbClr val="E5E1D8"/>
             </a:solidFill>
@@ -5469,8 +6043,8 @@
         </p:nvSpPr>
         <p:spPr>
           <a:xfrm>
-            <a:off x="4480559" y="1737360"/>
-            <a:ext cx="3200400" cy="457200"/>
+            <a:off x="4526279" y="1737360"/>
+            <a:ext cx="3108960" cy="457200"/>
           </a:xfrm>
           <a:prstGeom prst="rect">
             <a:avLst/>
@@ -5478,20 +6052,27 @@
           <a:noFill/>
         </p:spPr>
         <p:txBody>
-          <a:bodyPr wrap="square">
-            <a:spAutoFit/>
+          <a:bodyPr wrap="square" lIns="0" rIns="0" anchor="t">
+            <a:noAutofit/>
           </a:bodyPr>
           <a:lstStyle/>
           <a:p>
             <a:pPr algn="ctr">
-              <a:defRPr sz="1400" b="1">
+              <a:lnSpc>
+                <a:spcPct val="115000"/>
+              </a:lnSpc>
+              <a:defRPr sz="1300" b="1">
                 <a:solidFill>
                   <a:srgbClr val="111311"/>
                 </a:solidFill>
-                <a:latin typeface="Yu Gothic"/>
               </a:defRPr>
             </a:pPr>
             <a:r>
+              <a:rPr>
+                <a:latin typeface="Meiryo"/>
+                <a:ea typeface="Meiryo"/>
+                <a:cs typeface="Meiryo"/>
+              </a:rPr>
               <a:t>原因B：ゴール不明</a:t>
             </a:r>
           </a:p>
@@ -5505,8 +6086,8 @@
         </p:nvSpPr>
         <p:spPr>
           <a:xfrm>
-            <a:off x="4480559" y="2468880"/>
-            <a:ext cx="3200400" cy="1463040"/>
+            <a:off x="4526279" y="2377440"/>
+            <a:ext cx="3108960" cy="1463040"/>
           </a:xfrm>
           <a:prstGeom prst="rect">
             <a:avLst/>
@@ -5514,24 +6095,36 @@
           <a:noFill/>
         </p:spPr>
         <p:txBody>
-          <a:bodyPr wrap="square">
-            <a:spAutoFit/>
+          <a:bodyPr wrap="square" lIns="0" rIns="0" anchor="t">
+            <a:noAutofit/>
           </a:bodyPr>
           <a:lstStyle/>
           <a:p>
             <a:pPr algn="ctr">
-              <a:defRPr sz="1300" b="0">
+              <a:lnSpc>
+                <a:spcPct val="115000"/>
+              </a:lnSpc>
+              <a:defRPr sz="1200" b="0">
                 <a:solidFill>
                   <a:srgbClr val="333333"/>
                 </a:solidFill>
-                <a:latin typeface="Yu Gothic"/>
               </a:defRPr>
             </a:pPr>
             <a:r>
+              <a:rPr>
+                <a:latin typeface="Meiryo"/>
+                <a:ea typeface="Meiryo"/>
+                <a:cs typeface="Meiryo"/>
+              </a:rPr>
               <a:t>信頼できる30.5%</a:t>
             </a:r>
             <a:br/>
             <a:r>
+              <a:rPr>
+                <a:latin typeface="Meiryo"/>
+                <a:ea typeface="Meiryo"/>
+                <a:cs typeface="Meiryo"/>
+              </a:rPr>
               <a:t>保留42.0%で判断停止</a:t>
             </a:r>
           </a:p>
@@ -5545,8 +6138,8 @@
         </p:nvSpPr>
         <p:spPr>
           <a:xfrm>
-            <a:off x="5760719" y="4754880"/>
-            <a:ext cx="640080" cy="457200"/>
+            <a:off x="5852159" y="4617720"/>
+            <a:ext cx="457200" cy="457200"/>
           </a:xfrm>
           <a:prstGeom prst="rect">
             <a:avLst/>
@@ -5554,20 +6147,27 @@
           <a:noFill/>
         </p:spPr>
         <p:txBody>
-          <a:bodyPr wrap="square">
-            <a:spAutoFit/>
+          <a:bodyPr wrap="square" lIns="0" rIns="0" anchor="t">
+            <a:noAutofit/>
           </a:bodyPr>
           <a:lstStyle/>
           <a:p>
             <a:pPr algn="ctr">
-              <a:defRPr sz="1600" b="1">
+              <a:lnSpc>
+                <a:spcPct val="115000"/>
+              </a:lnSpc>
+              <a:defRPr sz="1400" b="1">
                 <a:solidFill>
                   <a:srgbClr val="B91C1C"/>
                 </a:solidFill>
-                <a:latin typeface="Yu Gothic"/>
               </a:defRPr>
             </a:pPr>
             <a:r>
+              <a:rPr>
+                <a:latin typeface="Meiryo"/>
+                <a:ea typeface="Meiryo"/>
+                <a:cs typeface="Meiryo"/>
+              </a:rPr>
               <a:t>▼</a:t>
             </a:r>
           </a:p>
@@ -5581,16 +6181,18 @@
         </p:nvSpPr>
         <p:spPr>
           <a:xfrm>
-            <a:off x="8046719" y="1554480"/>
-            <a:ext cx="3566160" cy="3108960"/>
+            <a:off x="8046719" y="1508760"/>
+            <a:ext cx="3566160" cy="3017520"/>
           </a:xfrm>
           <a:prstGeom prst="roundRect">
-            <a:avLst/>
+            <a:avLst>
+              <a:gd name="adj" fmla="val 12000"/>
+            </a:avLst>
           </a:prstGeom>
           <a:solidFill>
             <a:srgbClr val="FFFFFF"/>
           </a:solidFill>
-          <a:ln w="12700">
+          <a:ln w="15875">
             <a:solidFill>
               <a:srgbClr val="E5E1D8"/>
             </a:solidFill>
@@ -5626,8 +6228,8 @@
         </p:nvSpPr>
         <p:spPr>
           <a:xfrm>
-            <a:off x="8229599" y="1737360"/>
-            <a:ext cx="3200400" cy="457200"/>
+            <a:off x="8275319" y="1737360"/>
+            <a:ext cx="3108960" cy="457200"/>
           </a:xfrm>
           <a:prstGeom prst="rect">
             <a:avLst/>
@@ -5635,20 +6237,27 @@
           <a:noFill/>
         </p:spPr>
         <p:txBody>
-          <a:bodyPr wrap="square">
-            <a:spAutoFit/>
+          <a:bodyPr wrap="square" lIns="0" rIns="0" anchor="t">
+            <a:noAutofit/>
           </a:bodyPr>
           <a:lstStyle/>
           <a:p>
             <a:pPr algn="ctr">
-              <a:defRPr sz="1400" b="1">
+              <a:lnSpc>
+                <a:spcPct val="115000"/>
+              </a:lnSpc>
+              <a:defRPr sz="1300" b="1">
                 <a:solidFill>
                   <a:srgbClr val="111311"/>
                 </a:solidFill>
-                <a:latin typeface="Yu Gothic"/>
               </a:defRPr>
             </a:pPr>
             <a:r>
+              <a:rPr>
+                <a:latin typeface="Meiryo"/>
+                <a:ea typeface="Meiryo"/>
+                <a:cs typeface="Meiryo"/>
+              </a:rPr>
               <a:t>原因C：時期遅れ</a:t>
             </a:r>
           </a:p>
@@ -5662,8 +6271,8 @@
         </p:nvSpPr>
         <p:spPr>
           <a:xfrm>
-            <a:off x="8229599" y="2468880"/>
-            <a:ext cx="3200400" cy="1463040"/>
+            <a:off x="8275319" y="2377440"/>
+            <a:ext cx="3108960" cy="1463040"/>
           </a:xfrm>
           <a:prstGeom prst="rect">
             <a:avLst/>
@@ -5671,24 +6280,36 @@
           <a:noFill/>
         </p:spPr>
         <p:txBody>
-          <a:bodyPr wrap="square">
-            <a:spAutoFit/>
+          <a:bodyPr wrap="square" lIns="0" rIns="0" anchor="t">
+            <a:noAutofit/>
           </a:bodyPr>
           <a:lstStyle/>
           <a:p>
             <a:pPr algn="ctr">
-              <a:defRPr sz="1300" b="0">
+              <a:lnSpc>
+                <a:spcPct val="115000"/>
+              </a:lnSpc>
+              <a:defRPr sz="1200" b="0">
                 <a:solidFill>
                   <a:srgbClr val="333333"/>
                 </a:solidFill>
-                <a:latin typeface="Yu Gothic"/>
               </a:defRPr>
             </a:pPr>
             <a:r>
+              <a:rPr>
+                <a:latin typeface="Meiryo"/>
+                <a:ea typeface="Meiryo"/>
+                <a:cs typeface="Meiryo"/>
+              </a:rPr>
               <a:t>開始35%のみ</a:t>
             </a:r>
             <a:br/>
             <a:r>
+              <a:rPr>
+                <a:latin typeface="Meiryo"/>
+                <a:ea typeface="Meiryo"/>
+                <a:cs typeface="Meiryo"/>
+              </a:rPr>
               <a:t>秋に35.2%が逆戻り</a:t>
             </a:r>
           </a:p>
@@ -5702,8 +6323,8 @@
         </p:nvSpPr>
         <p:spPr>
           <a:xfrm>
-            <a:off x="9509759" y="4754880"/>
-            <a:ext cx="640080" cy="457200"/>
+            <a:off x="9601199" y="4617720"/>
+            <a:ext cx="457200" cy="457200"/>
           </a:xfrm>
           <a:prstGeom prst="rect">
             <a:avLst/>
@@ -5711,20 +6332,27 @@
           <a:noFill/>
         </p:spPr>
         <p:txBody>
-          <a:bodyPr wrap="square">
-            <a:spAutoFit/>
+          <a:bodyPr wrap="square" lIns="0" rIns="0" anchor="t">
+            <a:noAutofit/>
           </a:bodyPr>
           <a:lstStyle/>
           <a:p>
             <a:pPr algn="ctr">
-              <a:defRPr sz="1600" b="1">
+              <a:lnSpc>
+                <a:spcPct val="115000"/>
+              </a:lnSpc>
+              <a:defRPr sz="1400" b="1">
                 <a:solidFill>
                   <a:srgbClr val="B91C1C"/>
                 </a:solidFill>
-                <a:latin typeface="Yu Gothic"/>
               </a:defRPr>
             </a:pPr>
             <a:r>
+              <a:rPr>
+                <a:latin typeface="Meiryo"/>
+                <a:ea typeface="Meiryo"/>
+                <a:cs typeface="Meiryo"/>
+              </a:rPr>
               <a:t>▼</a:t>
             </a:r>
           </a:p>
@@ -5738,16 +6366,18 @@
         </p:nvSpPr>
         <p:spPr>
           <a:xfrm>
-            <a:off x="548640" y="5303520"/>
-            <a:ext cx="11064240" cy="914400"/>
+            <a:off x="548640" y="5166360"/>
+            <a:ext cx="11064240" cy="868680"/>
           </a:xfrm>
           <a:prstGeom prst="roundRect">
-            <a:avLst/>
+            <a:avLst>
+              <a:gd name="adj" fmla="val 12000"/>
+            </a:avLst>
           </a:prstGeom>
           <a:solidFill>
             <a:srgbClr val="111311"/>
           </a:solidFill>
-          <a:ln w="12700">
+          <a:ln w="15875">
             <a:solidFill>
               <a:srgbClr val="111311"/>
             </a:solidFill>
@@ -5783,8 +6413,8 @@
         </p:nvSpPr>
         <p:spPr>
           <a:xfrm>
-            <a:off x="822960" y="5486400"/>
-            <a:ext cx="10515600" cy="548640"/>
+            <a:off x="822960" y="5303520"/>
+            <a:ext cx="10515600" cy="594360"/>
           </a:xfrm>
           <a:prstGeom prst="rect">
             <a:avLst/>
@@ -5792,20 +6422,27 @@
           <a:noFill/>
         </p:spPr>
         <p:txBody>
-          <a:bodyPr wrap="square">
-            <a:spAutoFit/>
+          <a:bodyPr wrap="square" lIns="0" rIns="0" anchor="t">
+            <a:noAutofit/>
           </a:bodyPr>
           <a:lstStyle/>
           <a:p>
             <a:pPr algn="ctr">
-              <a:defRPr sz="1400" b="1">
+              <a:lnSpc>
+                <a:spcPct val="115000"/>
+              </a:lnSpc>
+              <a:defRPr sz="1300" b="1">
                 <a:solidFill>
                   <a:srgbClr val="FFFFFF"/>
                 </a:solidFill>
-                <a:latin typeface="Yu Gothic"/>
               </a:defRPr>
             </a:pPr>
             <a:r>
+              <a:rPr>
+                <a:latin typeface="Meiryo"/>
+                <a:ea typeface="Meiryo"/>
+                <a:cs typeface="Meiryo"/>
+              </a:rPr>
               <a:t>→ 土台ゼロで選考 → 落ちる → 戻る の往復で時間と自信を失う</a:t>
             </a:r>
           </a:p>
@@ -5845,8 +6482,8 @@
         </p:nvSpPr>
         <p:spPr>
           <a:xfrm>
-            <a:off x="548640" y="182880"/>
-            <a:ext cx="10972800" cy="365760"/>
+            <a:off x="548640" y="228600"/>
+            <a:ext cx="11064240" cy="365760"/>
           </a:xfrm>
           <a:prstGeom prst="rect">
             <a:avLst/>
@@ -5854,20 +6491,27 @@
           <a:noFill/>
         </p:spPr>
         <p:txBody>
-          <a:bodyPr wrap="square">
-            <a:spAutoFit/>
+          <a:bodyPr wrap="square" lIns="0" rIns="0" anchor="t">
+            <a:noAutofit/>
           </a:bodyPr>
           <a:lstStyle/>
           <a:p>
             <a:pPr algn="l">
+              <a:lnSpc>
+                <a:spcPct val="115000"/>
+              </a:lnSpc>
               <a:defRPr sz="1200" b="0">
                 <a:solidFill>
                   <a:srgbClr val="6B6F6B"/>
                 </a:solidFill>
-                <a:latin typeface="Yu Gothic"/>
               </a:defRPr>
             </a:pPr>
             <a:r>
+              <a:rPr>
+                <a:latin typeface="Meiryo"/>
+                <a:ea typeface="Meiryo"/>
+                <a:cs typeface="Meiryo"/>
+              </a:rPr>
               <a:t>(05) 課題分析② — 放置すると誰が損するか</a:t>
             </a:r>
           </a:p>
@@ -5881,8 +6525,8 @@
         </p:nvSpPr>
         <p:spPr>
           <a:xfrm>
-            <a:off x="548640" y="548640"/>
-            <a:ext cx="10972800" cy="731520"/>
+            <a:off x="548640" y="594360"/>
+            <a:ext cx="11064240" cy="731520"/>
           </a:xfrm>
           <a:prstGeom prst="rect">
             <a:avLst/>
@@ -5890,20 +6534,27 @@
           <a:noFill/>
         </p:spPr>
         <p:txBody>
-          <a:bodyPr wrap="square">
-            <a:spAutoFit/>
+          <a:bodyPr wrap="square" lIns="0" rIns="0" anchor="t">
+            <a:noAutofit/>
           </a:bodyPr>
           <a:lstStyle/>
           <a:p>
             <a:pPr algn="l">
-              <a:defRPr sz="3400" b="1">
+              <a:lnSpc>
+                <a:spcPct val="115000"/>
+              </a:lnSpc>
+              <a:defRPr sz="3000" b="1">
                 <a:solidFill>
                   <a:srgbClr val="111311"/>
                 </a:solidFill>
-                <a:latin typeface="Yu Gothic"/>
               </a:defRPr>
             </a:pPr>
             <a:r>
+              <a:rPr>
+                <a:latin typeface="Meiryo"/>
+                <a:ea typeface="Meiryo"/>
+                <a:cs typeface="Meiryo"/>
+              </a:rPr>
               <a:t>三者損失マトリクス。</a:t>
             </a:r>
           </a:p>
@@ -5917,16 +6568,18 @@
         </p:nvSpPr>
         <p:spPr>
           <a:xfrm>
-            <a:off x="548640" y="1554480"/>
-            <a:ext cx="11064240" cy="640080"/>
+            <a:off x="548640" y="1463040"/>
+            <a:ext cx="11064240" cy="548640"/>
           </a:xfrm>
           <a:prstGeom prst="roundRect">
-            <a:avLst/>
+            <a:avLst>
+              <a:gd name="adj" fmla="val 12000"/>
+            </a:avLst>
           </a:prstGeom>
           <a:solidFill>
             <a:srgbClr val="111311"/>
           </a:solidFill>
-          <a:ln w="12700">
+          <a:ln w="15875">
             <a:solidFill>
               <a:srgbClr val="111311"/>
             </a:solidFill>
@@ -5962,8 +6615,8 @@
         </p:nvSpPr>
         <p:spPr>
           <a:xfrm>
-            <a:off x="822960" y="1645920"/>
-            <a:ext cx="3474720" cy="457200"/>
+            <a:off x="868680" y="1536192"/>
+            <a:ext cx="2926080" cy="411480"/>
           </a:xfrm>
           <a:prstGeom prst="rect">
             <a:avLst/>
@@ -5971,17 +6624,19 @@
           <a:noFill/>
         </p:spPr>
         <p:txBody>
-          <a:bodyPr wrap="square">
-            <a:spAutoFit/>
+          <a:bodyPr wrap="square" lIns="0" rIns="0" anchor="t">
+            <a:noAutofit/>
           </a:bodyPr>
           <a:lstStyle/>
           <a:p>
             <a:pPr algn="ctr">
-              <a:defRPr sz="1300" b="1">
+              <a:lnSpc>
+                <a:spcPct val="115000"/>
+              </a:lnSpc>
+              <a:defRPr sz="1200" b="1">
                 <a:solidFill>
                   <a:srgbClr val="FFFFFF"/>
                 </a:solidFill>
-                <a:latin typeface="Yu Gothic"/>
               </a:defRPr>
             </a:pPr>
           </a:p>
@@ -5995,8 +6650,8 @@
         </p:nvSpPr>
         <p:spPr>
           <a:xfrm>
-            <a:off x="4480560" y="1645920"/>
-            <a:ext cx="3474720" cy="457200"/>
+            <a:off x="4023360" y="1536192"/>
+            <a:ext cx="3383280" cy="411480"/>
           </a:xfrm>
           <a:prstGeom prst="rect">
             <a:avLst/>
@@ -6004,20 +6659,27 @@
           <a:noFill/>
         </p:spPr>
         <p:txBody>
-          <a:bodyPr wrap="square">
-            <a:spAutoFit/>
+          <a:bodyPr wrap="square" lIns="0" rIns="0" anchor="t">
+            <a:noAutofit/>
           </a:bodyPr>
           <a:lstStyle/>
           <a:p>
             <a:pPr algn="ctr">
-              <a:defRPr sz="1300" b="1">
+              <a:lnSpc>
+                <a:spcPct val="115000"/>
+              </a:lnSpc>
+              <a:defRPr sz="1200" b="1">
                 <a:solidFill>
                   <a:srgbClr val="FFFFFF"/>
                 </a:solidFill>
-                <a:latin typeface="Yu Gothic"/>
               </a:defRPr>
             </a:pPr>
             <a:r>
+              <a:rPr>
+                <a:latin typeface="Meiryo"/>
+                <a:ea typeface="Meiryo"/>
+                <a:cs typeface="Meiryo"/>
+              </a:rPr>
               <a:t>短期（選考期）</a:t>
             </a:r>
           </a:p>
@@ -6031,8 +6693,8 @@
         </p:nvSpPr>
         <p:spPr>
           <a:xfrm>
-            <a:off x="8138160" y="1645920"/>
-            <a:ext cx="3474720" cy="457200"/>
+            <a:off x="7680960" y="1536192"/>
+            <a:ext cx="3383280" cy="411480"/>
           </a:xfrm>
           <a:prstGeom prst="rect">
             <a:avLst/>
@@ -6040,20 +6702,27 @@
           <a:noFill/>
         </p:spPr>
         <p:txBody>
-          <a:bodyPr wrap="square">
-            <a:spAutoFit/>
+          <a:bodyPr wrap="square" lIns="0" rIns="0" anchor="t">
+            <a:noAutofit/>
           </a:bodyPr>
           <a:lstStyle/>
           <a:p>
             <a:pPr algn="ctr">
-              <a:defRPr sz="1300" b="1">
+              <a:lnSpc>
+                <a:spcPct val="115000"/>
+              </a:lnSpc>
+              <a:defRPr sz="1200" b="1">
                 <a:solidFill>
                   <a:srgbClr val="FFFFFF"/>
                 </a:solidFill>
-                <a:latin typeface="Yu Gothic"/>
               </a:defRPr>
             </a:pPr>
             <a:r>
+              <a:rPr>
+                <a:latin typeface="Meiryo"/>
+                <a:ea typeface="Meiryo"/>
+                <a:cs typeface="Meiryo"/>
+              </a:rPr>
               <a:t>長期（入社後）</a:t>
             </a:r>
           </a:p>
@@ -6067,16 +6736,18 @@
         </p:nvSpPr>
         <p:spPr>
           <a:xfrm>
-            <a:off x="548640" y="2377440"/>
-            <a:ext cx="11064240" cy="914400"/>
+            <a:off x="548640" y="2148840"/>
+            <a:ext cx="11064240" cy="960120"/>
           </a:xfrm>
           <a:prstGeom prst="roundRect">
-            <a:avLst/>
+            <a:avLst>
+              <a:gd name="adj" fmla="val 12000"/>
+            </a:avLst>
           </a:prstGeom>
           <a:solidFill>
             <a:srgbClr val="FFFFFF"/>
           </a:solidFill>
-          <a:ln w="12700">
+          <a:ln w="15875">
             <a:solidFill>
               <a:srgbClr val="E5E1D8"/>
             </a:solidFill>
@@ -6112,8 +6783,8 @@
         </p:nvSpPr>
         <p:spPr>
           <a:xfrm>
-            <a:off x="822960" y="2514600"/>
-            <a:ext cx="2926080" cy="640080"/>
+            <a:off x="868680" y="2258568"/>
+            <a:ext cx="2926080" cy="731520"/>
           </a:xfrm>
           <a:prstGeom prst="rect">
             <a:avLst/>
@@ -6121,20 +6792,27 @@
           <a:noFill/>
         </p:spPr>
         <p:txBody>
-          <a:bodyPr wrap="square">
-            <a:spAutoFit/>
+          <a:bodyPr wrap="square" lIns="0" rIns="0" anchor="t">
+            <a:noAutofit/>
           </a:bodyPr>
           <a:lstStyle/>
           <a:p>
             <a:pPr algn="ctr">
-              <a:defRPr sz="1400" b="1">
+              <a:lnSpc>
+                <a:spcPct val="115000"/>
+              </a:lnSpc>
+              <a:defRPr sz="1300" b="1">
                 <a:solidFill>
                   <a:srgbClr val="111311"/>
                 </a:solidFill>
-                <a:latin typeface="Yu Gothic"/>
               </a:defRPr>
             </a:pPr>
             <a:r>
+              <a:rPr>
+                <a:latin typeface="Meiryo"/>
+                <a:ea typeface="Meiryo"/>
+                <a:cs typeface="Meiryo"/>
+              </a:rPr>
               <a:t>学生</a:t>
             </a:r>
           </a:p>
@@ -6148,8 +6826,8 @@
         </p:nvSpPr>
         <p:spPr>
           <a:xfrm>
-            <a:off x="4023360" y="2514600"/>
-            <a:ext cx="3291840" cy="640080"/>
+            <a:off x="4023360" y="2258568"/>
+            <a:ext cx="3383280" cy="731520"/>
           </a:xfrm>
           <a:prstGeom prst="rect">
             <a:avLst/>
@@ -6157,20 +6835,27 @@
           <a:noFill/>
         </p:spPr>
         <p:txBody>
-          <a:bodyPr wrap="square">
-            <a:spAutoFit/>
+          <a:bodyPr wrap="square" lIns="0" rIns="0" anchor="t">
+            <a:noAutofit/>
           </a:bodyPr>
           <a:lstStyle/>
           <a:p>
             <a:pPr algn="ctr">
-              <a:defRPr sz="1200" b="0">
+              <a:lnSpc>
+                <a:spcPct val="115000"/>
+              </a:lnSpc>
+              <a:defRPr sz="1100" b="0">
                 <a:solidFill>
                   <a:srgbClr val="111311"/>
                 </a:solidFill>
-                <a:latin typeface="Yu Gothic"/>
               </a:defRPr>
             </a:pPr>
             <a:r>
+              <a:rPr>
+                <a:latin typeface="Meiryo"/>
+                <a:ea typeface="Meiryo"/>
+                <a:cs typeface="Meiryo"/>
+              </a:rPr>
               <a:t>自信なき応募・手戻り</a:t>
             </a:r>
           </a:p>
@@ -6184,8 +6869,8 @@
         </p:nvSpPr>
         <p:spPr>
           <a:xfrm>
-            <a:off x="7680960" y="2514600"/>
-            <a:ext cx="3291840" cy="640080"/>
+            <a:off x="7680960" y="2258568"/>
+            <a:ext cx="3383280" cy="731520"/>
           </a:xfrm>
           <a:prstGeom prst="rect">
             <a:avLst/>
@@ -6193,20 +6878,27 @@
           <a:noFill/>
         </p:spPr>
         <p:txBody>
-          <a:bodyPr wrap="square">
-            <a:spAutoFit/>
+          <a:bodyPr wrap="square" lIns="0" rIns="0" anchor="t">
+            <a:noAutofit/>
           </a:bodyPr>
           <a:lstStyle/>
           <a:p>
             <a:pPr algn="ctr">
-              <a:defRPr sz="1200" b="0">
+              <a:lnSpc>
+                <a:spcPct val="115000"/>
+              </a:lnSpc>
+              <a:defRPr sz="1100" b="0">
                 <a:solidFill>
                   <a:srgbClr val="111311"/>
                 </a:solidFill>
-                <a:latin typeface="Yu Gothic"/>
               </a:defRPr>
             </a:pPr>
             <a:r>
+              <a:rPr>
+                <a:latin typeface="Meiryo"/>
+                <a:ea typeface="Meiryo"/>
+                <a:cs typeface="Meiryo"/>
+              </a:rPr>
               <a:t>納得低下・ミスマッチ</a:t>
             </a:r>
           </a:p>
@@ -6220,16 +6912,18 @@
         </p:nvSpPr>
         <p:spPr>
           <a:xfrm>
-            <a:off x="548640" y="3429000"/>
-            <a:ext cx="11064240" cy="914400"/>
+            <a:off x="548640" y="3227832"/>
+            <a:ext cx="11064240" cy="960120"/>
           </a:xfrm>
           <a:prstGeom prst="roundRect">
-            <a:avLst/>
+            <a:avLst>
+              <a:gd name="adj" fmla="val 12000"/>
+            </a:avLst>
           </a:prstGeom>
           <a:solidFill>
             <a:srgbClr val="FFFFFF"/>
           </a:solidFill>
-          <a:ln w="12700">
+          <a:ln w="15875">
             <a:solidFill>
               <a:srgbClr val="E5E1D8"/>
             </a:solidFill>
@@ -6265,8 +6959,8 @@
         </p:nvSpPr>
         <p:spPr>
           <a:xfrm>
-            <a:off x="822960" y="3566160"/>
-            <a:ext cx="2926080" cy="640080"/>
+            <a:off x="868680" y="3337560"/>
+            <a:ext cx="2926080" cy="731520"/>
           </a:xfrm>
           <a:prstGeom prst="rect">
             <a:avLst/>
@@ -6274,20 +6968,27 @@
           <a:noFill/>
         </p:spPr>
         <p:txBody>
-          <a:bodyPr wrap="square">
-            <a:spAutoFit/>
+          <a:bodyPr wrap="square" lIns="0" rIns="0" anchor="t">
+            <a:noAutofit/>
           </a:bodyPr>
           <a:lstStyle/>
           <a:p>
             <a:pPr algn="ctr">
-              <a:defRPr sz="1400" b="1">
+              <a:lnSpc>
+                <a:spcPct val="115000"/>
+              </a:lnSpc>
+              <a:defRPr sz="1300" b="1">
                 <a:solidFill>
                   <a:srgbClr val="111311"/>
                 </a:solidFill>
-                <a:latin typeface="Yu Gothic"/>
               </a:defRPr>
             </a:pPr>
             <a:r>
+              <a:rPr>
+                <a:latin typeface="Meiryo"/>
+                <a:ea typeface="Meiryo"/>
+                <a:cs typeface="Meiryo"/>
+              </a:rPr>
               <a:t>企業</a:t>
             </a:r>
           </a:p>
@@ -6301,8 +7002,8 @@
         </p:nvSpPr>
         <p:spPr>
           <a:xfrm>
-            <a:off x="4023360" y="3566160"/>
-            <a:ext cx="3291840" cy="640080"/>
+            <a:off x="4023360" y="3337560"/>
+            <a:ext cx="3383280" cy="731520"/>
           </a:xfrm>
           <a:prstGeom prst="rect">
             <a:avLst/>
@@ -6310,20 +7011,27 @@
           <a:noFill/>
         </p:spPr>
         <p:txBody>
-          <a:bodyPr wrap="square">
-            <a:spAutoFit/>
+          <a:bodyPr wrap="square" lIns="0" rIns="0" anchor="t">
+            <a:noAutofit/>
           </a:bodyPr>
           <a:lstStyle/>
           <a:p>
             <a:pPr algn="ctr">
-              <a:defRPr sz="1200" b="0">
+              <a:lnSpc>
+                <a:spcPct val="115000"/>
+              </a:lnSpc>
+              <a:defRPr sz="1100" b="0">
                 <a:solidFill>
                   <a:srgbClr val="111311"/>
                 </a:solidFill>
-                <a:latin typeface="Yu Gothic"/>
               </a:defRPr>
             </a:pPr>
             <a:r>
+              <a:rPr>
+                <a:latin typeface="Meiryo"/>
+                <a:ea typeface="Meiryo"/>
+                <a:cs typeface="Meiryo"/>
+              </a:rPr>
               <a:t>人柄93.8%を評価不能</a:t>
             </a:r>
           </a:p>
@@ -6337,8 +7045,8 @@
         </p:nvSpPr>
         <p:spPr>
           <a:xfrm>
-            <a:off x="7680960" y="3566160"/>
-            <a:ext cx="3291840" cy="640080"/>
+            <a:off x="7680960" y="3337560"/>
+            <a:ext cx="3383280" cy="731520"/>
           </a:xfrm>
           <a:prstGeom prst="rect">
             <a:avLst/>
@@ -6346,20 +7054,27 @@
           <a:noFill/>
         </p:spPr>
         <p:txBody>
-          <a:bodyPr wrap="square">
-            <a:spAutoFit/>
+          <a:bodyPr wrap="square" lIns="0" rIns="0" anchor="t">
+            <a:noAutofit/>
           </a:bodyPr>
           <a:lstStyle/>
           <a:p>
             <a:pPr algn="ctr">
-              <a:defRPr sz="1200" b="0">
+              <a:lnSpc>
+                <a:spcPct val="115000"/>
+              </a:lnSpc>
+              <a:defRPr sz="1100" b="0">
                 <a:solidFill>
                   <a:srgbClr val="111311"/>
                 </a:solidFill>
-                <a:latin typeface="Yu Gothic"/>
               </a:defRPr>
             </a:pPr>
             <a:r>
+              <a:rPr>
+                <a:latin typeface="Meiryo"/>
+                <a:ea typeface="Meiryo"/>
+                <a:cs typeface="Meiryo"/>
+              </a:rPr>
               <a:t>採用・定着コスト増</a:t>
             </a:r>
           </a:p>
@@ -6373,16 +7088,18 @@
         </p:nvSpPr>
         <p:spPr>
           <a:xfrm>
-            <a:off x="548640" y="4480560"/>
-            <a:ext cx="11064240" cy="914400"/>
+            <a:off x="548640" y="4306824"/>
+            <a:ext cx="11064240" cy="960120"/>
           </a:xfrm>
           <a:prstGeom prst="roundRect">
-            <a:avLst/>
+            <a:avLst>
+              <a:gd name="adj" fmla="val 12000"/>
+            </a:avLst>
           </a:prstGeom>
           <a:solidFill>
             <a:srgbClr val="FFFFFF"/>
           </a:solidFill>
-          <a:ln w="12700">
+          <a:ln w="15875">
             <a:solidFill>
               <a:srgbClr val="E5E1D8"/>
             </a:solidFill>
@@ -6418,8 +7135,8 @@
         </p:nvSpPr>
         <p:spPr>
           <a:xfrm>
-            <a:off x="822960" y="4617720"/>
-            <a:ext cx="2926080" cy="640080"/>
+            <a:off x="868680" y="4416552"/>
+            <a:ext cx="2926080" cy="731520"/>
           </a:xfrm>
           <a:prstGeom prst="rect">
             <a:avLst/>
@@ -6427,20 +7144,27 @@
           <a:noFill/>
         </p:spPr>
         <p:txBody>
-          <a:bodyPr wrap="square">
-            <a:spAutoFit/>
+          <a:bodyPr wrap="square" lIns="0" rIns="0" anchor="t">
+            <a:noAutofit/>
           </a:bodyPr>
           <a:lstStyle/>
           <a:p>
             <a:pPr algn="ctr">
-              <a:defRPr sz="1400" b="1">
+              <a:lnSpc>
+                <a:spcPct val="115000"/>
+              </a:lnSpc>
+              <a:defRPr sz="1300" b="1">
                 <a:solidFill>
                   <a:srgbClr val="111311"/>
                 </a:solidFill>
-                <a:latin typeface="Yu Gothic"/>
               </a:defRPr>
             </a:pPr>
             <a:r>
+              <a:rPr>
+                <a:latin typeface="Meiryo"/>
+                <a:ea typeface="Meiryo"/>
+                <a:cs typeface="Meiryo"/>
+              </a:rPr>
               <a:t>社会</a:t>
             </a:r>
           </a:p>
@@ -6454,8 +7178,8 @@
         </p:nvSpPr>
         <p:spPr>
           <a:xfrm>
-            <a:off x="4023360" y="4617720"/>
-            <a:ext cx="3291840" cy="640080"/>
+            <a:off x="4023360" y="4416552"/>
+            <a:ext cx="3383280" cy="731520"/>
           </a:xfrm>
           <a:prstGeom prst="rect">
             <a:avLst/>
@@ -6463,20 +7187,27 @@
           <a:noFill/>
         </p:spPr>
         <p:txBody>
-          <a:bodyPr wrap="square">
-            <a:spAutoFit/>
+          <a:bodyPr wrap="square" lIns="0" rIns="0" anchor="t">
+            <a:noAutofit/>
           </a:bodyPr>
           <a:lstStyle/>
           <a:p>
             <a:pPr algn="ctr">
-              <a:defRPr sz="1200" b="0">
+              <a:lnSpc>
+                <a:spcPct val="115000"/>
+              </a:lnSpc>
+              <a:defRPr sz="1100" b="0">
                 <a:solidFill>
                   <a:srgbClr val="111311"/>
                 </a:solidFill>
-                <a:latin typeface="Yu Gothic"/>
               </a:defRPr>
             </a:pPr>
             <a:r>
+              <a:rPr>
+                <a:latin typeface="Meiryo"/>
+                <a:ea typeface="Meiryo"/>
+                <a:cs typeface="Meiryo"/>
+              </a:rPr>
               <a:t>支援の手戻り</a:t>
             </a:r>
           </a:p>
@@ -6490,8 +7221,8 @@
         </p:nvSpPr>
         <p:spPr>
           <a:xfrm>
-            <a:off x="7680960" y="4617720"/>
-            <a:ext cx="3291840" cy="640080"/>
+            <a:off x="7680960" y="4416552"/>
+            <a:ext cx="3383280" cy="731520"/>
           </a:xfrm>
           <a:prstGeom prst="rect">
             <a:avLst/>
@@ -6499,20 +7230,27 @@
           <a:noFill/>
         </p:spPr>
         <p:txBody>
-          <a:bodyPr wrap="square">
-            <a:spAutoFit/>
+          <a:bodyPr wrap="square" lIns="0" rIns="0" anchor="t">
+            <a:noAutofit/>
           </a:bodyPr>
           <a:lstStyle/>
           <a:p>
             <a:pPr algn="ctr">
-              <a:defRPr sz="1200" b="0">
+              <a:lnSpc>
+                <a:spcPct val="115000"/>
+              </a:lnSpc>
+              <a:defRPr sz="1100" b="0">
                 <a:solidFill>
                   <a:srgbClr val="111311"/>
                 </a:solidFill>
-                <a:latin typeface="Yu Gothic"/>
               </a:defRPr>
             </a:pPr>
             <a:r>
+              <a:rPr>
+                <a:latin typeface="Meiryo"/>
+                <a:ea typeface="Meiryo"/>
+                <a:cs typeface="Meiryo"/>
+              </a:rPr>
               <a:t>早期離職・40%ギャップ</a:t>
             </a:r>
           </a:p>
@@ -6526,8 +7264,8 @@
         </p:nvSpPr>
         <p:spPr>
           <a:xfrm>
-            <a:off x="548640" y="5760720"/>
-            <a:ext cx="10972800" cy="457200"/>
+            <a:off x="548640" y="5486400"/>
+            <a:ext cx="11064240" cy="548640"/>
           </a:xfrm>
           <a:prstGeom prst="rect">
             <a:avLst/>
@@ -6535,20 +7273,27 @@
           <a:noFill/>
         </p:spPr>
         <p:txBody>
-          <a:bodyPr wrap="square">
-            <a:spAutoFit/>
+          <a:bodyPr wrap="square" lIns="0" rIns="0" anchor="t">
+            <a:noAutofit/>
           </a:bodyPr>
           <a:lstStyle/>
           <a:p>
             <a:pPr algn="ctr">
-              <a:defRPr sz="1200" b="0">
+              <a:lnSpc>
+                <a:spcPct val="115000"/>
+              </a:lnSpc>
+              <a:defRPr sz="1100" b="0">
                 <a:solidFill>
                   <a:srgbClr val="6B6F6B"/>
                 </a:solidFill>
-                <a:latin typeface="Yu Gothic"/>
               </a:defRPr>
             </a:pPr>
             <a:r>
+              <a:rPr>
+                <a:latin typeface="Meiryo"/>
+                <a:ea typeface="Meiryo"/>
+                <a:cs typeface="Meiryo"/>
+              </a:rPr>
               <a:t>だから解決に社会的価値がある ／ 出典：白書93.8%・社会人40%・学情60.7%</a:t>
             </a:r>
           </a:p>
@@ -6588,8 +7333,8 @@
         </p:nvSpPr>
         <p:spPr>
           <a:xfrm>
-            <a:off x="548640" y="182880"/>
-            <a:ext cx="10972800" cy="365760"/>
+            <a:off x="548640" y="228600"/>
+            <a:ext cx="11064240" cy="365760"/>
           </a:xfrm>
           <a:prstGeom prst="rect">
             <a:avLst/>
@@ -6597,20 +7342,27 @@
           <a:noFill/>
         </p:spPr>
         <p:txBody>
-          <a:bodyPr wrap="square">
-            <a:spAutoFit/>
+          <a:bodyPr wrap="square" lIns="0" rIns="0" anchor="t">
+            <a:noAutofit/>
           </a:bodyPr>
           <a:lstStyle/>
           <a:p>
             <a:pPr algn="l">
+              <a:lnSpc>
+                <a:spcPct val="115000"/>
+              </a:lnSpc>
               <a:defRPr sz="1200" b="0">
                 <a:solidFill>
                   <a:srgbClr val="6B6F6B"/>
                 </a:solidFill>
-                <a:latin typeface="Yu Gothic"/>
               </a:defRPr>
             </a:pPr>
             <a:r>
+              <a:rPr>
+                <a:latin typeface="Meiryo"/>
+                <a:ea typeface="Meiryo"/>
+                <a:cs typeface="Meiryo"/>
+              </a:rPr>
               <a:t>(06) まとめ &amp; 次へ</a:t>
             </a:r>
           </a:p>
@@ -6624,8 +7376,8 @@
         </p:nvSpPr>
         <p:spPr>
           <a:xfrm>
-            <a:off x="548640" y="548640"/>
-            <a:ext cx="10972800" cy="822960"/>
+            <a:off x="548640" y="594360"/>
+            <a:ext cx="11064240" cy="822960"/>
           </a:xfrm>
           <a:prstGeom prst="rect">
             <a:avLst/>
@@ -6633,20 +7385,27 @@
           <a:noFill/>
         </p:spPr>
         <p:txBody>
-          <a:bodyPr wrap="square">
-            <a:spAutoFit/>
+          <a:bodyPr wrap="square" lIns="0" rIns="0" anchor="t">
+            <a:noAutofit/>
           </a:bodyPr>
           <a:lstStyle/>
           <a:p>
             <a:pPr algn="l">
-              <a:defRPr sz="3400" b="1">
+              <a:lnSpc>
+                <a:spcPct val="115000"/>
+              </a:lnSpc>
+              <a:defRPr sz="3000" b="1">
                 <a:solidFill>
                   <a:srgbClr val="111311"/>
                 </a:solidFill>
-                <a:latin typeface="Yu Gothic"/>
               </a:defRPr>
             </a:pPr>
             <a:r>
+              <a:rPr>
+                <a:latin typeface="Meiryo"/>
+                <a:ea typeface="Meiryo"/>
+                <a:cs typeface="Meiryo"/>
+              </a:rPr>
               <a:t>一文で持ち帰る。</a:t>
             </a:r>
           </a:p>
@@ -6660,16 +7419,18 @@
         </p:nvSpPr>
         <p:spPr>
           <a:xfrm>
-            <a:off x="548640" y="1645920"/>
-            <a:ext cx="11064240" cy="1645920"/>
+            <a:off x="548640" y="1554480"/>
+            <a:ext cx="11064240" cy="1554480"/>
           </a:xfrm>
           <a:prstGeom prst="roundRect">
-            <a:avLst/>
+            <a:avLst>
+              <a:gd name="adj" fmla="val 12000"/>
+            </a:avLst>
           </a:prstGeom>
           <a:solidFill>
             <a:srgbClr val="FFFFFF"/>
           </a:solidFill>
-          <a:ln w="12700">
+          <a:ln w="15875">
             <a:solidFill>
               <a:srgbClr val="B91C1C"/>
             </a:solidFill>
@@ -6705,8 +7466,8 @@
         </p:nvSpPr>
         <p:spPr>
           <a:xfrm>
-            <a:off x="914400" y="1828800"/>
-            <a:ext cx="10332720" cy="1280160"/>
+            <a:off x="1005840" y="1783080"/>
+            <a:ext cx="10149840" cy="1097280"/>
           </a:xfrm>
           <a:prstGeom prst="rect">
             <a:avLst/>
@@ -6714,20 +7475,27 @@
           <a:noFill/>
         </p:spPr>
         <p:txBody>
-          <a:bodyPr wrap="square">
-            <a:spAutoFit/>
+          <a:bodyPr wrap="square" lIns="0" rIns="0" anchor="t">
+            <a:noAutofit/>
           </a:bodyPr>
           <a:lstStyle/>
           <a:p>
             <a:pPr algn="ctr">
-              <a:defRPr sz="1800" b="1">
+              <a:lnSpc>
+                <a:spcPct val="115000"/>
+              </a:lnSpc>
+              <a:defRPr sz="1700" b="1">
                 <a:solidFill>
                   <a:srgbClr val="B91C1C"/>
                 </a:solidFill>
-                <a:latin typeface="Yu Gothic"/>
               </a:defRPr>
             </a:pPr>
             <a:r>
+              <a:rPr>
+                <a:latin typeface="Meiryo"/>
+                <a:ea typeface="Meiryo"/>
+                <a:cs typeface="Meiryo"/>
+              </a:rPr>
               <a:t>問題は「自己分析の質とタイミングのギャップ」である。</a:t>
             </a:r>
           </a:p>
@@ -6741,16 +7509,18 @@
         </p:nvSpPr>
         <p:spPr>
           <a:xfrm>
-            <a:off x="548640" y="3657600"/>
-            <a:ext cx="5486400" cy="2194560"/>
+            <a:off x="548640" y="3383280"/>
+            <a:ext cx="5486400" cy="2286000"/>
           </a:xfrm>
           <a:prstGeom prst="roundRect">
-            <a:avLst/>
+            <a:avLst>
+              <a:gd name="adj" fmla="val 12000"/>
+            </a:avLst>
           </a:prstGeom>
           <a:solidFill>
             <a:srgbClr val="FFFFFF"/>
           </a:solidFill>
-          <a:ln w="12700">
+          <a:ln w="15875">
             <a:solidFill>
               <a:srgbClr val="E5E1D8"/>
             </a:solidFill>
@@ -6786,8 +7556,8 @@
         </p:nvSpPr>
         <p:spPr>
           <a:xfrm>
-            <a:off x="822960" y="3840480"/>
-            <a:ext cx="4937760" cy="1828800"/>
+            <a:off x="868680" y="3611880"/>
+            <a:ext cx="4846320" cy="1828800"/>
           </a:xfrm>
           <a:prstGeom prst="rect">
             <a:avLst/>
@@ -6795,28 +7565,76 @@
           <a:noFill/>
         </p:spPr>
         <p:txBody>
-          <a:bodyPr wrap="square">
-            <a:spAutoFit/>
+          <a:bodyPr wrap="square" anchor="t">
+            <a:noAutofit/>
           </a:bodyPr>
           <a:lstStyle/>
           <a:p>
-            <a:pPr algn="l">
-              <a:defRPr sz="1400" b="0">
-                <a:solidFill>
-                  <a:srgbClr val="111311"/>
-                </a:solidFill>
-                <a:latin typeface="Yu Gothic"/>
+            <a:pPr>
+              <a:lnSpc>
+                <a:spcPct val="120000"/>
+              </a:lnSpc>
+              <a:spcAft>
+                <a:spcPts val="300"/>
+              </a:spcAft>
+              <a:defRPr sz="1300">
+                <a:solidFill>
+                  <a:srgbClr val="333333"/>
+                </a:solidFill>
               </a:defRPr>
             </a:pPr>
             <a:r>
+              <a:rPr>
+                <a:latin typeface="Meiryo"/>
+                <a:ea typeface="Meiryo"/>
+                <a:cs typeface="Meiryo"/>
+              </a:rPr>
               <a:t>次回1：原因の深掘り</a:t>
             </a:r>
-            <a:br/>
-            <a:r>
+          </a:p>
+          <a:p>
+            <a:pPr>
+              <a:lnSpc>
+                <a:spcPct val="120000"/>
+              </a:lnSpc>
+              <a:spcAft>
+                <a:spcPts val="300"/>
+              </a:spcAft>
+              <a:defRPr sz="1300">
+                <a:solidFill>
+                  <a:srgbClr val="333333"/>
+                </a:solidFill>
+              </a:defRPr>
+            </a:pPr>
+            <a:r>
+              <a:rPr>
+                <a:latin typeface="Meiryo"/>
+                <a:ea typeface="Meiryo"/>
+                <a:cs typeface="Meiryo"/>
+              </a:rPr>
               <a:t>次回2：既存支援の調査</a:t>
             </a:r>
-            <a:br/>
-            <a:r>
+          </a:p>
+          <a:p>
+            <a:pPr>
+              <a:lnSpc>
+                <a:spcPct val="120000"/>
+              </a:lnSpc>
+              <a:spcAft>
+                <a:spcPts val="300"/>
+              </a:spcAft>
+              <a:defRPr sz="1300">
+                <a:solidFill>
+                  <a:srgbClr val="333333"/>
+                </a:solidFill>
+              </a:defRPr>
+            </a:pPr>
+            <a:r>
+              <a:rPr>
+                <a:latin typeface="Meiryo"/>
+                <a:ea typeface="Meiryo"/>
+                <a:cs typeface="Meiryo"/>
+              </a:rPr>
               <a:t>次回3：解決方向の検討</a:t>
             </a:r>
           </a:p>
@@ -6830,16 +7648,18 @@
         </p:nvSpPr>
         <p:spPr>
           <a:xfrm>
-            <a:off x="6126480" y="3657600"/>
-            <a:ext cx="5486400" cy="2194560"/>
+            <a:off x="6126480" y="3383280"/>
+            <a:ext cx="5486400" cy="2286000"/>
           </a:xfrm>
           <a:prstGeom prst="roundRect">
-            <a:avLst/>
+            <a:avLst>
+              <a:gd name="adj" fmla="val 12000"/>
+            </a:avLst>
           </a:prstGeom>
           <a:solidFill>
             <a:srgbClr val="FFFFFF"/>
           </a:solidFill>
-          <a:ln w="12700">
+          <a:ln w="15875">
             <a:solidFill>
               <a:srgbClr val="E5E1D8"/>
             </a:solidFill>
@@ -6875,7 +7695,7 @@
         </p:nvSpPr>
         <p:spPr>
           <a:xfrm>
-            <a:off x="6400800" y="3840480"/>
+            <a:off x="6400800" y="3611880"/>
             <a:ext cx="4937760" cy="1828800"/>
           </a:xfrm>
           <a:prstGeom prst="rect">
@@ -6884,24 +7704,36 @@
           <a:noFill/>
         </p:spPr>
         <p:txBody>
-          <a:bodyPr wrap="square">
-            <a:spAutoFit/>
+          <a:bodyPr wrap="square" lIns="0" rIns="0" anchor="t">
+            <a:noAutofit/>
           </a:bodyPr>
           <a:lstStyle/>
           <a:p>
             <a:pPr algn="l">
+              <a:lnSpc>
+                <a:spcPct val="115000"/>
+              </a:lnSpc>
               <a:defRPr sz="1400" b="1">
                 <a:solidFill>
                   <a:srgbClr val="111311"/>
                 </a:solidFill>
-                <a:latin typeface="Yu Gothic"/>
               </a:defRPr>
             </a:pPr>
             <a:r>
+              <a:rPr>
+                <a:latin typeface="Meiryo"/>
+                <a:ea typeface="Meiryo"/>
+                <a:cs typeface="Meiryo"/>
+              </a:rPr>
               <a:t>発表の締め：</a:t>
             </a:r>
             <a:br/>
             <a:r>
+              <a:rPr>
+                <a:latin typeface="Meiryo"/>
+                <a:ea typeface="Meiryo"/>
+                <a:cs typeface="Meiryo"/>
+              </a:rPr>
               <a:t>“なんとなく就活”をなくすために</a:t>
             </a:r>
           </a:p>
@@ -6915,8 +7747,8 @@
         </p:nvSpPr>
         <p:spPr>
           <a:xfrm>
-            <a:off x="548640" y="6126480"/>
-            <a:ext cx="10972800" cy="365760"/>
+            <a:off x="548640" y="6035040"/>
+            <a:ext cx="11064240" cy="365760"/>
           </a:xfrm>
           <a:prstGeom prst="rect">
             <a:avLst/>
@@ -6924,20 +7756,27 @@
           <a:noFill/>
         </p:spPr>
         <p:txBody>
-          <a:bodyPr wrap="square">
-            <a:spAutoFit/>
+          <a:bodyPr wrap="square" lIns="0" rIns="0" anchor="t">
+            <a:noAutofit/>
           </a:bodyPr>
           <a:lstStyle/>
           <a:p>
             <a:pPr algn="ctr">
+              <a:lnSpc>
+                <a:spcPct val="115000"/>
+              </a:lnSpc>
               <a:defRPr sz="1000" b="0">
                 <a:solidFill>
                   <a:srgbClr val="6B6F6B"/>
                 </a:solidFill>
-                <a:latin typeface="Yu Gothic"/>
               </a:defRPr>
             </a:pPr>
             <a:r>
+              <a:rPr>
+                <a:latin typeface="Meiryo"/>
+                <a:ea typeface="Meiryo"/>
+                <a:cs typeface="Meiryo"/>
+              </a:rPr>
               <a:t>資料： https://taku010201040.github.io/jibun-mayogo-2026/</a:t>
             </a:r>
           </a:p>

</xml_diff>